<commit_message>
Split workflow slide into two visual slides (25 + 26)
Slide 25: step-by-step workflow (Business Question → Fonti → AI Synthesis
→ Human Validation → Insight) with source tags and speaker note.
Slide 26: full 15-source ecosystem map (Una mappa, non una scelta)
with color-coded grid by source category.

Co-Authored-By: Claude Sonnet 4.6 <noreply@anthropic.com>
Claude-Session: https://claude.ai/code/session_012BJMKNkvQJ6bNjyTN4A4ZY
</commit_message>
<xml_diff>
--- a/Social_Listening_Speech_FINAL.pptx
+++ b/Social_Listening_Speech_FINAL.pptx
@@ -29,7 +29,8 @@
     <p:sldId id="277" r:id="rId28"/>
     <p:sldId id="278" r:id="rId29"/>
     <p:sldId id="279" r:id="rId30"/>
-    <p:sldId id="280" r:id="rId31"/>
+    <p:sldId id="289" r:id="rId40"/>
+    <p:sldId id="290" r:id="rId41"/>
     <p:sldId id="281" r:id="rId32"/>
     <p:sldId id="282" r:id="rId33"/>
     <p:sldId id="283" r:id="rId34"/>
@@ -12076,6 +12077,3441 @@
                 <a:latin typeface="Courier New"/>
               </a:rPr>
               <a:t>Q&amp;A A SEGUIRE · VINCENZO ALBERTO MARRARI · EY STUDIO+ / TRAJAAN</a:t>
+            </a:r>
+          </a:p>
+        </p:txBody>
+      </p:sp>
+    </p:spTree>
+  </p:cSld>
+  <p:clrMapOvr>
+    <a:masterClrMapping/>
+  </p:clrMapOvr>
+</p:sld>
+</file>
+
+<file path=ppt/slides/slide34.xml><?xml version="1.0" encoding="utf-8"?>
+<p:sld xmlns:a="http://schemas.openxmlformats.org/drawingml/2006/main" xmlns:p="http://schemas.openxmlformats.org/presentationml/2006/main" xmlns:r="http://schemas.openxmlformats.org/officeDocument/2006/relationships">
+  <p:cSld>
+    <p:bg>
+      <p:bgPr>
+        <a:solidFill>
+          <a:srgbClr val="F3EDE1"/>
+        </a:solidFill>
+        <a:effectLst/>
+      </p:bgPr>
+    </p:bg>
+    <p:spTree>
+      <p:nvGrpSpPr>
+        <p:cNvPr id="1" name=""/>
+        <p:cNvGrpSpPr/>
+        <p:nvPr/>
+      </p:nvGrpSpPr>
+      <p:grpSpPr/>
+      <p:sp>
+        <p:nvSpPr>
+          <p:cNvPr id="2" name="TextBox 1"/>
+          <p:cNvSpPr txBox="1"/>
+          <p:nvPr/>
+        </p:nvSpPr>
+        <p:spPr>
+          <a:xfrm>
+            <a:off x="914400" y="914400"/>
+            <a:ext cx="16459200" cy="365760"/>
+          </a:xfrm>
+          <a:prstGeom prst="rect">
+            <a:avLst/>
+          </a:prstGeom>
+          <a:noFill/>
+        </p:spPr>
+        <p:txBody>
+          <a:bodyPr wrap="none">
+            <a:spAutoFit/>
+          </a:bodyPr>
+          <a:lstStyle/>
+          <a:p>
+            <a:r>
+              <a:rPr sz="1800">
+                <a:solidFill>
+                  <a:srgbClr val="B8523A"/>
+                </a:solidFill>
+                <a:latin typeface="Courier New"/>
+              </a:rPr>
+              <a:t>● </a:t>
+            </a:r>
+            <a:r>
+              <a:rPr sz="1800">
+                <a:solidFill>
+                  <a:srgbClr val="8A8175"/>
+                </a:solidFill>
+                <a:latin typeface="Courier New"/>
+              </a:rPr>
+              <a:t>IL NUOVO WORKFLOW DELL'INSIGHT ANALYST</a:t>
+            </a:r>
+          </a:p>
+        </p:txBody>
+      </p:sp>
+      <p:sp>
+        <p:nvSpPr>
+          <p:cNvPr id="3" name="TextBox 2"/>
+          <p:cNvSpPr txBox="1"/>
+          <p:nvPr/>
+        </p:nvSpPr>
+        <p:spPr>
+          <a:xfrm>
+            <a:off x="914400" y="1371600"/>
+            <a:ext cx="15544800" cy="1097280"/>
+          </a:xfrm>
+          <a:prstGeom prst="rect">
+            <a:avLst/>
+          </a:prstGeom>
+          <a:noFill/>
+        </p:spPr>
+        <p:txBody>
+          <a:bodyPr wrap="square">
+            <a:spAutoFit/>
+          </a:bodyPr>
+          <a:lstStyle/>
+          <a:p>
+            <a:r>
+              <a:rPr sz="4200">
+                <a:solidFill>
+                  <a:srgbClr val="1A1714"/>
+                </a:solidFill>
+                <a:latin typeface="Georgia"/>
+              </a:rPr>
+              <a:t>Dall'analisi di una fonte </a:t>
+            </a:r>
+            <a:r>
+              <a:rPr sz="4200">
+                <a:solidFill>
+                  <a:srgbClr val="B8523A"/>
+                </a:solidFill>
+                <a:latin typeface="Georgia"/>
+              </a:rPr>
+              <a:t>all'orchestrazione di un ecosistema.</a:t>
+            </a:r>
+          </a:p>
+        </p:txBody>
+      </p:sp>
+      <p:sp>
+        <p:nvSpPr>
+          <p:cNvPr id="4" name="Rectangle 3"/>
+          <p:cNvSpPr/>
+          <p:nvPr/>
+        </p:nvSpPr>
+        <p:spPr>
+          <a:xfrm>
+            <a:off x="731520" y="3108960"/>
+            <a:ext cx="2743200" cy="2560320"/>
+          </a:xfrm>
+          <a:prstGeom prst="rect">
+            <a:avLst/>
+          </a:prstGeom>
+          <a:solidFill>
+            <a:srgbClr val="1A1714"/>
+          </a:solidFill>
+          <a:ln>
+            <a:noFill/>
+          </a:ln>
+        </p:spPr>
+        <p:style>
+          <a:lnRef idx="1">
+            <a:schemeClr val="accent1"/>
+          </a:lnRef>
+          <a:fillRef idx="3">
+            <a:schemeClr val="accent1"/>
+          </a:fillRef>
+          <a:effectRef idx="2">
+            <a:schemeClr val="accent1"/>
+          </a:effectRef>
+          <a:fontRef idx="minor">
+            <a:schemeClr val="lt1"/>
+          </a:fontRef>
+        </p:style>
+        <p:txBody>
+          <a:bodyPr rtlCol="0" anchor="ctr"/>
+          <a:lstStyle/>
+          <a:p>
+            <a:pPr algn="ctr"/>
+          </a:p>
+        </p:txBody>
+      </p:sp>
+      <p:sp>
+        <p:nvSpPr>
+          <p:cNvPr id="5" name="TextBox 4"/>
+          <p:cNvSpPr txBox="1"/>
+          <p:nvPr/>
+        </p:nvSpPr>
+        <p:spPr>
+          <a:xfrm>
+            <a:off x="868680" y="3218688"/>
+            <a:ext cx="548640" cy="365760"/>
+          </a:xfrm>
+          <a:prstGeom prst="rect">
+            <a:avLst/>
+          </a:prstGeom>
+          <a:noFill/>
+        </p:spPr>
+        <p:txBody>
+          <a:bodyPr wrap="square">
+            <a:spAutoFit/>
+          </a:bodyPr>
+          <a:lstStyle/>
+          <a:p>
+            <a:r>
+              <a:rPr sz="1300" b="0">
+                <a:solidFill>
+                  <a:srgbClr val="EBE4D3"/>
+                </a:solidFill>
+                <a:latin typeface="Courier New"/>
+              </a:rPr>
+              <a:t>01</a:t>
+            </a:r>
+          </a:p>
+        </p:txBody>
+      </p:sp>
+      <p:sp>
+        <p:nvSpPr>
+          <p:cNvPr id="6" name="TextBox 5"/>
+          <p:cNvSpPr txBox="1"/>
+          <p:nvPr/>
+        </p:nvSpPr>
+        <p:spPr>
+          <a:xfrm>
+            <a:off x="868680" y="3611880"/>
+            <a:ext cx="2468880" cy="822960"/>
+          </a:xfrm>
+          <a:prstGeom prst="rect">
+            <a:avLst/>
+          </a:prstGeom>
+          <a:noFill/>
+        </p:spPr>
+        <p:txBody>
+          <a:bodyPr wrap="square">
+            <a:spAutoFit/>
+          </a:bodyPr>
+          <a:lstStyle/>
+          <a:p>
+            <a:r>
+              <a:rPr sz="2100" b="1">
+                <a:solidFill>
+                  <a:srgbClr val="F3EDE1"/>
+                </a:solidFill>
+                <a:latin typeface="Georgia"/>
+              </a:rPr>
+              <a:t>BUSINESS
+QUESTION</a:t>
+            </a:r>
+          </a:p>
+        </p:txBody>
+      </p:sp>
+      <p:sp>
+        <p:nvSpPr>
+          <p:cNvPr id="7" name="TextBox 6"/>
+          <p:cNvSpPr txBox="1"/>
+          <p:nvPr/>
+        </p:nvSpPr>
+        <p:spPr>
+          <a:xfrm>
+            <a:off x="868680" y="4572000"/>
+            <a:ext cx="2468880" cy="914400"/>
+          </a:xfrm>
+          <a:prstGeom prst="rect">
+            <a:avLst/>
+          </a:prstGeom>
+          <a:noFill/>
+        </p:spPr>
+        <p:txBody>
+          <a:bodyPr wrap="square">
+            <a:spAutoFit/>
+          </a:bodyPr>
+          <a:lstStyle/>
+          <a:p>
+            <a:r>
+              <a:rPr sz="1400" b="0">
+                <a:solidFill>
+                  <a:srgbClr val="F3EDE1"/>
+                </a:solidFill>
+                <a:latin typeface="Arial"/>
+              </a:rPr>
+              <a:t>Quale decisione
+devo supportare?</a:t>
+            </a:r>
+          </a:p>
+        </p:txBody>
+      </p:sp>
+      <p:sp>
+        <p:nvSpPr>
+          <p:cNvPr id="8" name="TextBox 7"/>
+          <p:cNvSpPr txBox="1"/>
+          <p:nvPr/>
+        </p:nvSpPr>
+        <p:spPr>
+          <a:xfrm>
+            <a:off x="3511296" y="4114800"/>
+            <a:ext cx="274320" cy="457200"/>
+          </a:xfrm>
+          <a:prstGeom prst="rect">
+            <a:avLst/>
+          </a:prstGeom>
+          <a:noFill/>
+        </p:spPr>
+        <p:txBody>
+          <a:bodyPr wrap="square">
+            <a:spAutoFit/>
+          </a:bodyPr>
+          <a:lstStyle/>
+          <a:p>
+            <a:r>
+              <a:rPr sz="2600" b="0">
+                <a:solidFill>
+                  <a:srgbClr val="B8523A"/>
+                </a:solidFill>
+                <a:latin typeface="Georgia"/>
+              </a:rPr>
+              <a:t>→</a:t>
+            </a:r>
+          </a:p>
+        </p:txBody>
+      </p:sp>
+      <p:sp>
+        <p:nvSpPr>
+          <p:cNvPr id="9" name="Rectangle 8"/>
+          <p:cNvSpPr/>
+          <p:nvPr/>
+        </p:nvSpPr>
+        <p:spPr>
+          <a:xfrm>
+            <a:off x="3794760" y="3108960"/>
+            <a:ext cx="2743200" cy="2560320"/>
+          </a:xfrm>
+          <a:prstGeom prst="rect">
+            <a:avLst/>
+          </a:prstGeom>
+          <a:solidFill>
+            <a:srgbClr val="B8523A"/>
+          </a:solidFill>
+          <a:ln>
+            <a:noFill/>
+          </a:ln>
+        </p:spPr>
+        <p:style>
+          <a:lnRef idx="1">
+            <a:schemeClr val="accent1"/>
+          </a:lnRef>
+          <a:fillRef idx="3">
+            <a:schemeClr val="accent1"/>
+          </a:fillRef>
+          <a:effectRef idx="2">
+            <a:schemeClr val="accent1"/>
+          </a:effectRef>
+          <a:fontRef idx="minor">
+            <a:schemeClr val="lt1"/>
+          </a:fontRef>
+        </p:style>
+        <p:txBody>
+          <a:bodyPr rtlCol="0" anchor="ctr"/>
+          <a:lstStyle/>
+          <a:p>
+            <a:pPr algn="ctr"/>
+          </a:p>
+        </p:txBody>
+      </p:sp>
+      <p:sp>
+        <p:nvSpPr>
+          <p:cNvPr id="10" name="TextBox 9"/>
+          <p:cNvSpPr txBox="1"/>
+          <p:nvPr/>
+        </p:nvSpPr>
+        <p:spPr>
+          <a:xfrm>
+            <a:off x="3931920" y="3218688"/>
+            <a:ext cx="548640" cy="365760"/>
+          </a:xfrm>
+          <a:prstGeom prst="rect">
+            <a:avLst/>
+          </a:prstGeom>
+          <a:noFill/>
+        </p:spPr>
+        <p:txBody>
+          <a:bodyPr wrap="square">
+            <a:spAutoFit/>
+          </a:bodyPr>
+          <a:lstStyle/>
+          <a:p>
+            <a:r>
+              <a:rPr sz="1300" b="0">
+                <a:solidFill>
+                  <a:srgbClr val="EBE4D3"/>
+                </a:solidFill>
+                <a:latin typeface="Courier New"/>
+              </a:rPr>
+              <a:t>02</a:t>
+            </a:r>
+          </a:p>
+        </p:txBody>
+      </p:sp>
+      <p:sp>
+        <p:nvSpPr>
+          <p:cNvPr id="11" name="TextBox 10"/>
+          <p:cNvSpPr txBox="1"/>
+          <p:nvPr/>
+        </p:nvSpPr>
+        <p:spPr>
+          <a:xfrm>
+            <a:off x="3931920" y="3611880"/>
+            <a:ext cx="2468880" cy="822960"/>
+          </a:xfrm>
+          <a:prstGeom prst="rect">
+            <a:avLst/>
+          </a:prstGeom>
+          <a:noFill/>
+        </p:spPr>
+        <p:txBody>
+          <a:bodyPr wrap="square">
+            <a:spAutoFit/>
+          </a:bodyPr>
+          <a:lstStyle/>
+          <a:p>
+            <a:r>
+              <a:rPr sz="2100" b="1">
+                <a:solidFill>
+                  <a:srgbClr val="F3EDE1"/>
+                </a:solidFill>
+                <a:latin typeface="Georgia"/>
+              </a:rPr>
+              <a:t>FONTI
+MULTIPLE</a:t>
+            </a:r>
+          </a:p>
+        </p:txBody>
+      </p:sp>
+      <p:sp>
+        <p:nvSpPr>
+          <p:cNvPr id="12" name="TextBox 11"/>
+          <p:cNvSpPr txBox="1"/>
+          <p:nvPr/>
+        </p:nvSpPr>
+        <p:spPr>
+          <a:xfrm>
+            <a:off x="3931920" y="4572000"/>
+            <a:ext cx="2468880" cy="914400"/>
+          </a:xfrm>
+          <a:prstGeom prst="rect">
+            <a:avLst/>
+          </a:prstGeom>
+          <a:noFill/>
+        </p:spPr>
+        <p:txBody>
+          <a:bodyPr wrap="square">
+            <a:spAutoFit/>
+          </a:bodyPr>
+          <a:lstStyle/>
+          <a:p>
+            <a:r>
+              <a:rPr sz="1400" b="0">
+                <a:solidFill>
+                  <a:srgbClr val="F3EDE1"/>
+                </a:solidFill>
+                <a:latin typeface="Arial"/>
+              </a:rPr>
+              <a:t>Social, search,
+survey, CRM...</a:t>
+            </a:r>
+          </a:p>
+        </p:txBody>
+      </p:sp>
+      <p:sp>
+        <p:nvSpPr>
+          <p:cNvPr id="13" name="TextBox 12"/>
+          <p:cNvSpPr txBox="1"/>
+          <p:nvPr/>
+        </p:nvSpPr>
+        <p:spPr>
+          <a:xfrm>
+            <a:off x="6574536" y="4114800"/>
+            <a:ext cx="274320" cy="457200"/>
+          </a:xfrm>
+          <a:prstGeom prst="rect">
+            <a:avLst/>
+          </a:prstGeom>
+          <a:noFill/>
+        </p:spPr>
+        <p:txBody>
+          <a:bodyPr wrap="square">
+            <a:spAutoFit/>
+          </a:bodyPr>
+          <a:lstStyle/>
+          <a:p>
+            <a:r>
+              <a:rPr sz="2600" b="0">
+                <a:solidFill>
+                  <a:srgbClr val="B8523A"/>
+                </a:solidFill>
+                <a:latin typeface="Georgia"/>
+              </a:rPr>
+              <a:t>→</a:t>
+            </a:r>
+          </a:p>
+        </p:txBody>
+      </p:sp>
+      <p:sp>
+        <p:nvSpPr>
+          <p:cNvPr id="14" name="Rectangle 13"/>
+          <p:cNvSpPr/>
+          <p:nvPr/>
+        </p:nvSpPr>
+        <p:spPr>
+          <a:xfrm>
+            <a:off x="6858000" y="3108960"/>
+            <a:ext cx="2743200" cy="2560320"/>
+          </a:xfrm>
+          <a:prstGeom prst="rect">
+            <a:avLst/>
+          </a:prstGeom>
+          <a:solidFill>
+            <a:srgbClr val="3D3833"/>
+          </a:solidFill>
+          <a:ln>
+            <a:noFill/>
+          </a:ln>
+        </p:spPr>
+        <p:style>
+          <a:lnRef idx="1">
+            <a:schemeClr val="accent1"/>
+          </a:lnRef>
+          <a:fillRef idx="3">
+            <a:schemeClr val="accent1"/>
+          </a:fillRef>
+          <a:effectRef idx="2">
+            <a:schemeClr val="accent1"/>
+          </a:effectRef>
+          <a:fontRef idx="minor">
+            <a:schemeClr val="lt1"/>
+          </a:fontRef>
+        </p:style>
+        <p:txBody>
+          <a:bodyPr rtlCol="0" anchor="ctr"/>
+          <a:lstStyle/>
+          <a:p>
+            <a:pPr algn="ctr"/>
+          </a:p>
+        </p:txBody>
+      </p:sp>
+      <p:sp>
+        <p:nvSpPr>
+          <p:cNvPr id="15" name="TextBox 14"/>
+          <p:cNvSpPr txBox="1"/>
+          <p:nvPr/>
+        </p:nvSpPr>
+        <p:spPr>
+          <a:xfrm>
+            <a:off x="6995160" y="3218688"/>
+            <a:ext cx="548640" cy="365760"/>
+          </a:xfrm>
+          <a:prstGeom prst="rect">
+            <a:avLst/>
+          </a:prstGeom>
+          <a:noFill/>
+        </p:spPr>
+        <p:txBody>
+          <a:bodyPr wrap="square">
+            <a:spAutoFit/>
+          </a:bodyPr>
+          <a:lstStyle/>
+          <a:p>
+            <a:r>
+              <a:rPr sz="1300" b="0">
+                <a:solidFill>
+                  <a:srgbClr val="EBE4D3"/>
+                </a:solidFill>
+                <a:latin typeface="Courier New"/>
+              </a:rPr>
+              <a:t>03</a:t>
+            </a:r>
+          </a:p>
+        </p:txBody>
+      </p:sp>
+      <p:sp>
+        <p:nvSpPr>
+          <p:cNvPr id="16" name="TextBox 15"/>
+          <p:cNvSpPr txBox="1"/>
+          <p:nvPr/>
+        </p:nvSpPr>
+        <p:spPr>
+          <a:xfrm>
+            <a:off x="6995160" y="3611880"/>
+            <a:ext cx="2468880" cy="822960"/>
+          </a:xfrm>
+          <a:prstGeom prst="rect">
+            <a:avLst/>
+          </a:prstGeom>
+          <a:noFill/>
+        </p:spPr>
+        <p:txBody>
+          <a:bodyPr wrap="square">
+            <a:spAutoFit/>
+          </a:bodyPr>
+          <a:lstStyle/>
+          <a:p>
+            <a:r>
+              <a:rPr sz="2100" b="1">
+                <a:solidFill>
+                  <a:srgbClr val="EBE4D3"/>
+                </a:solidFill>
+                <a:latin typeface="Georgia"/>
+              </a:rPr>
+              <a:t>AI
+SYNTHESIS</a:t>
+            </a:r>
+          </a:p>
+        </p:txBody>
+      </p:sp>
+      <p:sp>
+        <p:nvSpPr>
+          <p:cNvPr id="17" name="TextBox 16"/>
+          <p:cNvSpPr txBox="1"/>
+          <p:nvPr/>
+        </p:nvSpPr>
+        <p:spPr>
+          <a:xfrm>
+            <a:off x="6995160" y="4572000"/>
+            <a:ext cx="2468880" cy="914400"/>
+          </a:xfrm>
+          <a:prstGeom prst="rect">
+            <a:avLst/>
+          </a:prstGeom>
+          <a:noFill/>
+        </p:spPr>
+        <p:txBody>
+          <a:bodyPr wrap="square">
+            <a:spAutoFit/>
+          </a:bodyPr>
+          <a:lstStyle/>
+          <a:p>
+            <a:r>
+              <a:rPr sz="1400" b="0">
+                <a:solidFill>
+                  <a:srgbClr val="EBE4D3"/>
+                </a:solidFill>
+                <a:latin typeface="Arial"/>
+              </a:rPr>
+              <a:t>Clustering,
+pattern, sintesi</a:t>
+            </a:r>
+          </a:p>
+        </p:txBody>
+      </p:sp>
+      <p:sp>
+        <p:nvSpPr>
+          <p:cNvPr id="18" name="TextBox 17"/>
+          <p:cNvSpPr txBox="1"/>
+          <p:nvPr/>
+        </p:nvSpPr>
+        <p:spPr>
+          <a:xfrm>
+            <a:off x="9637776" y="4114800"/>
+            <a:ext cx="274320" cy="457200"/>
+          </a:xfrm>
+          <a:prstGeom prst="rect">
+            <a:avLst/>
+          </a:prstGeom>
+          <a:noFill/>
+        </p:spPr>
+        <p:txBody>
+          <a:bodyPr wrap="square">
+            <a:spAutoFit/>
+          </a:bodyPr>
+          <a:lstStyle/>
+          <a:p>
+            <a:r>
+              <a:rPr sz="2600" b="0">
+                <a:solidFill>
+                  <a:srgbClr val="B8523A"/>
+                </a:solidFill>
+                <a:latin typeface="Georgia"/>
+              </a:rPr>
+              <a:t>→</a:t>
+            </a:r>
+          </a:p>
+        </p:txBody>
+      </p:sp>
+      <p:sp>
+        <p:nvSpPr>
+          <p:cNvPr id="19" name="Rectangle 18"/>
+          <p:cNvSpPr/>
+          <p:nvPr/>
+        </p:nvSpPr>
+        <p:spPr>
+          <a:xfrm>
+            <a:off x="9921240" y="3108960"/>
+            <a:ext cx="2743200" cy="2560320"/>
+          </a:xfrm>
+          <a:prstGeom prst="rect">
+            <a:avLst/>
+          </a:prstGeom>
+          <a:solidFill>
+            <a:srgbClr val="8A8175"/>
+          </a:solidFill>
+          <a:ln>
+            <a:noFill/>
+          </a:ln>
+        </p:spPr>
+        <p:style>
+          <a:lnRef idx="1">
+            <a:schemeClr val="accent1"/>
+          </a:lnRef>
+          <a:fillRef idx="3">
+            <a:schemeClr val="accent1"/>
+          </a:fillRef>
+          <a:effectRef idx="2">
+            <a:schemeClr val="accent1"/>
+          </a:effectRef>
+          <a:fontRef idx="minor">
+            <a:schemeClr val="lt1"/>
+          </a:fontRef>
+        </p:style>
+        <p:txBody>
+          <a:bodyPr rtlCol="0" anchor="ctr"/>
+          <a:lstStyle/>
+          <a:p>
+            <a:pPr algn="ctr"/>
+          </a:p>
+        </p:txBody>
+      </p:sp>
+      <p:sp>
+        <p:nvSpPr>
+          <p:cNvPr id="20" name="TextBox 19"/>
+          <p:cNvSpPr txBox="1"/>
+          <p:nvPr/>
+        </p:nvSpPr>
+        <p:spPr>
+          <a:xfrm>
+            <a:off x="10058400" y="3218688"/>
+            <a:ext cx="548640" cy="365760"/>
+          </a:xfrm>
+          <a:prstGeom prst="rect">
+            <a:avLst/>
+          </a:prstGeom>
+          <a:noFill/>
+        </p:spPr>
+        <p:txBody>
+          <a:bodyPr wrap="square">
+            <a:spAutoFit/>
+          </a:bodyPr>
+          <a:lstStyle/>
+          <a:p>
+            <a:r>
+              <a:rPr sz="1300" b="0">
+                <a:solidFill>
+                  <a:srgbClr val="3D3833"/>
+                </a:solidFill>
+                <a:latin typeface="Courier New"/>
+              </a:rPr>
+              <a:t>04</a:t>
+            </a:r>
+          </a:p>
+        </p:txBody>
+      </p:sp>
+      <p:sp>
+        <p:nvSpPr>
+          <p:cNvPr id="21" name="TextBox 20"/>
+          <p:cNvSpPr txBox="1"/>
+          <p:nvPr/>
+        </p:nvSpPr>
+        <p:spPr>
+          <a:xfrm>
+            <a:off x="10058400" y="3611880"/>
+            <a:ext cx="2468880" cy="822960"/>
+          </a:xfrm>
+          <a:prstGeom prst="rect">
+            <a:avLst/>
+          </a:prstGeom>
+          <a:noFill/>
+        </p:spPr>
+        <p:txBody>
+          <a:bodyPr wrap="square">
+            <a:spAutoFit/>
+          </a:bodyPr>
+          <a:lstStyle/>
+          <a:p>
+            <a:r>
+              <a:rPr sz="2100" b="1">
+                <a:solidFill>
+                  <a:srgbClr val="F3EDE1"/>
+                </a:solidFill>
+                <a:latin typeface="Georgia"/>
+              </a:rPr>
+              <a:t>HUMAN
+VALIDATION</a:t>
+            </a:r>
+          </a:p>
+        </p:txBody>
+      </p:sp>
+      <p:sp>
+        <p:nvSpPr>
+          <p:cNvPr id="22" name="TextBox 21"/>
+          <p:cNvSpPr txBox="1"/>
+          <p:nvPr/>
+        </p:nvSpPr>
+        <p:spPr>
+          <a:xfrm>
+            <a:off x="10058400" y="4572000"/>
+            <a:ext cx="2468880" cy="914400"/>
+          </a:xfrm>
+          <a:prstGeom prst="rect">
+            <a:avLst/>
+          </a:prstGeom>
+          <a:noFill/>
+        </p:spPr>
+        <p:txBody>
+          <a:bodyPr wrap="square">
+            <a:spAutoFit/>
+          </a:bodyPr>
+          <a:lstStyle/>
+          <a:p>
+            <a:r>
+              <a:rPr sz="1400" b="0">
+                <a:solidFill>
+                  <a:srgbClr val="F3EDE1"/>
+                </a:solidFill>
+                <a:latin typeface="Arial"/>
+              </a:rPr>
+              <a:t>Contesto,
+bias, rilevanza</a:t>
+            </a:r>
+          </a:p>
+        </p:txBody>
+      </p:sp>
+      <p:sp>
+        <p:nvSpPr>
+          <p:cNvPr id="23" name="TextBox 22"/>
+          <p:cNvSpPr txBox="1"/>
+          <p:nvPr/>
+        </p:nvSpPr>
+        <p:spPr>
+          <a:xfrm>
+            <a:off x="12701016" y="4114800"/>
+            <a:ext cx="274320" cy="457200"/>
+          </a:xfrm>
+          <a:prstGeom prst="rect">
+            <a:avLst/>
+          </a:prstGeom>
+          <a:noFill/>
+        </p:spPr>
+        <p:txBody>
+          <a:bodyPr wrap="square">
+            <a:spAutoFit/>
+          </a:bodyPr>
+          <a:lstStyle/>
+          <a:p>
+            <a:r>
+              <a:rPr sz="2600" b="0">
+                <a:solidFill>
+                  <a:srgbClr val="B8523A"/>
+                </a:solidFill>
+                <a:latin typeface="Georgia"/>
+              </a:rPr>
+              <a:t>→</a:t>
+            </a:r>
+          </a:p>
+        </p:txBody>
+      </p:sp>
+      <p:sp>
+        <p:nvSpPr>
+          <p:cNvPr id="24" name="Rectangle 23"/>
+          <p:cNvSpPr/>
+          <p:nvPr/>
+        </p:nvSpPr>
+        <p:spPr>
+          <a:xfrm>
+            <a:off x="12984480" y="3108960"/>
+            <a:ext cx="2743200" cy="2560320"/>
+          </a:xfrm>
+          <a:prstGeom prst="rect">
+            <a:avLst/>
+          </a:prstGeom>
+          <a:solidFill>
+            <a:srgbClr val="B8523A"/>
+          </a:solidFill>
+          <a:ln>
+            <a:noFill/>
+          </a:ln>
+        </p:spPr>
+        <p:style>
+          <a:lnRef idx="1">
+            <a:schemeClr val="accent1"/>
+          </a:lnRef>
+          <a:fillRef idx="3">
+            <a:schemeClr val="accent1"/>
+          </a:fillRef>
+          <a:effectRef idx="2">
+            <a:schemeClr val="accent1"/>
+          </a:effectRef>
+          <a:fontRef idx="minor">
+            <a:schemeClr val="lt1"/>
+          </a:fontRef>
+        </p:style>
+        <p:txBody>
+          <a:bodyPr rtlCol="0" anchor="ctr"/>
+          <a:lstStyle/>
+          <a:p>
+            <a:pPr algn="ctr"/>
+          </a:p>
+        </p:txBody>
+      </p:sp>
+      <p:sp>
+        <p:nvSpPr>
+          <p:cNvPr id="25" name="TextBox 24"/>
+          <p:cNvSpPr txBox="1"/>
+          <p:nvPr/>
+        </p:nvSpPr>
+        <p:spPr>
+          <a:xfrm>
+            <a:off x="13121640" y="3218688"/>
+            <a:ext cx="548640" cy="365760"/>
+          </a:xfrm>
+          <a:prstGeom prst="rect">
+            <a:avLst/>
+          </a:prstGeom>
+          <a:noFill/>
+        </p:spPr>
+        <p:txBody>
+          <a:bodyPr wrap="square">
+            <a:spAutoFit/>
+          </a:bodyPr>
+          <a:lstStyle/>
+          <a:p>
+            <a:r>
+              <a:rPr sz="1300" b="0">
+                <a:solidFill>
+                  <a:srgbClr val="EBE4D3"/>
+                </a:solidFill>
+                <a:latin typeface="Courier New"/>
+              </a:rPr>
+              <a:t>05</a:t>
+            </a:r>
+          </a:p>
+        </p:txBody>
+      </p:sp>
+      <p:sp>
+        <p:nvSpPr>
+          <p:cNvPr id="26" name="TextBox 25"/>
+          <p:cNvSpPr txBox="1"/>
+          <p:nvPr/>
+        </p:nvSpPr>
+        <p:spPr>
+          <a:xfrm>
+            <a:off x="13121640" y="3611880"/>
+            <a:ext cx="2468880" cy="822960"/>
+          </a:xfrm>
+          <a:prstGeom prst="rect">
+            <a:avLst/>
+          </a:prstGeom>
+          <a:noFill/>
+        </p:spPr>
+        <p:txBody>
+          <a:bodyPr wrap="square">
+            <a:spAutoFit/>
+          </a:bodyPr>
+          <a:lstStyle/>
+          <a:p>
+            <a:r>
+              <a:rPr sz="2100" b="1">
+                <a:solidFill>
+                  <a:srgbClr val="F3EDE1"/>
+                </a:solidFill>
+                <a:latin typeface="Georgia"/>
+              </a:rPr>
+              <a:t>INSIGHT
+DECISIONE</a:t>
+            </a:r>
+          </a:p>
+        </p:txBody>
+      </p:sp>
+      <p:sp>
+        <p:nvSpPr>
+          <p:cNvPr id="27" name="TextBox 26"/>
+          <p:cNvSpPr txBox="1"/>
+          <p:nvPr/>
+        </p:nvSpPr>
+        <p:spPr>
+          <a:xfrm>
+            <a:off x="13121640" y="4572000"/>
+            <a:ext cx="2468880" cy="914400"/>
+          </a:xfrm>
+          <a:prstGeom prst="rect">
+            <a:avLst/>
+          </a:prstGeom>
+          <a:noFill/>
+        </p:spPr>
+        <p:txBody>
+          <a:bodyPr wrap="square">
+            <a:spAutoFit/>
+          </a:bodyPr>
+          <a:lstStyle/>
+          <a:p>
+            <a:r>
+              <a:rPr sz="1400" b="0">
+                <a:solidFill>
+                  <a:srgbClr val="F3EDE1"/>
+                </a:solidFill>
+                <a:latin typeface="Arial"/>
+              </a:rPr>
+              <a:t>Il dato orienta,
+non commenta</a:t>
+            </a:r>
+          </a:p>
+        </p:txBody>
+      </p:sp>
+      <p:sp>
+        <p:nvSpPr>
+          <p:cNvPr id="28" name="TextBox 27"/>
+          <p:cNvSpPr txBox="1"/>
+          <p:nvPr/>
+        </p:nvSpPr>
+        <p:spPr>
+          <a:xfrm>
+            <a:off x="914400" y="6035040"/>
+            <a:ext cx="15544800" cy="365760"/>
+          </a:xfrm>
+          <a:prstGeom prst="rect">
+            <a:avLst/>
+          </a:prstGeom>
+          <a:noFill/>
+        </p:spPr>
+        <p:txBody>
+          <a:bodyPr wrap="square">
+            <a:spAutoFit/>
+          </a:bodyPr>
+          <a:lstStyle/>
+          <a:p>
+            <a:r>
+              <a:rPr sz="1300" b="0">
+                <a:solidFill>
+                  <a:srgbClr val="8A8175"/>
+                </a:solidFill>
+                <a:latin typeface="Courier New"/>
+              </a:rPr>
+              <a:t>FONTI CHE ALIMENTANO IL WORKFLOW</a:t>
+            </a:r>
+          </a:p>
+        </p:txBody>
+      </p:sp>
+      <p:sp>
+        <p:nvSpPr>
+          <p:cNvPr id="29" name="Rectangle 28"/>
+          <p:cNvSpPr/>
+          <p:nvPr/>
+        </p:nvSpPr>
+        <p:spPr>
+          <a:xfrm>
+            <a:off x="822960" y="6583680"/>
+            <a:ext cx="2249424" cy="411480"/>
+          </a:xfrm>
+          <a:prstGeom prst="rect">
+            <a:avLst/>
+          </a:prstGeom>
+          <a:solidFill>
+            <a:srgbClr val="E0D8CC"/>
+          </a:solidFill>
+          <a:ln>
+            <a:noFill/>
+          </a:ln>
+        </p:spPr>
+        <p:style>
+          <a:lnRef idx="1">
+            <a:schemeClr val="accent1"/>
+          </a:lnRef>
+          <a:fillRef idx="3">
+            <a:schemeClr val="accent1"/>
+          </a:fillRef>
+          <a:effectRef idx="2">
+            <a:schemeClr val="accent1"/>
+          </a:effectRef>
+          <a:fontRef idx="minor">
+            <a:schemeClr val="lt1"/>
+          </a:fontRef>
+        </p:style>
+        <p:txBody>
+          <a:bodyPr rtlCol="0" anchor="ctr"/>
+          <a:lstStyle/>
+          <a:p>
+            <a:pPr algn="ctr"/>
+          </a:p>
+        </p:txBody>
+      </p:sp>
+      <p:sp>
+        <p:nvSpPr>
+          <p:cNvPr id="30" name="TextBox 29"/>
+          <p:cNvSpPr txBox="1"/>
+          <p:nvPr/>
+        </p:nvSpPr>
+        <p:spPr>
+          <a:xfrm>
+            <a:off x="914400" y="6647688"/>
+            <a:ext cx="2066544" cy="320040"/>
+          </a:xfrm>
+          <a:prstGeom prst="rect">
+            <a:avLst/>
+          </a:prstGeom>
+          <a:noFill/>
+        </p:spPr>
+        <p:txBody>
+          <a:bodyPr wrap="square">
+            <a:spAutoFit/>
+          </a:bodyPr>
+          <a:lstStyle/>
+          <a:p>
+            <a:r>
+              <a:rPr sz="1200" b="0">
+                <a:solidFill>
+                  <a:srgbClr val="3D3833"/>
+                </a:solidFill>
+                <a:latin typeface="Courier New"/>
+              </a:rPr>
+              <a:t>Social Listening</a:t>
+            </a:r>
+          </a:p>
+        </p:txBody>
+      </p:sp>
+      <p:sp>
+        <p:nvSpPr>
+          <p:cNvPr id="31" name="Rectangle 30"/>
+          <p:cNvSpPr/>
+          <p:nvPr/>
+        </p:nvSpPr>
+        <p:spPr>
+          <a:xfrm>
+            <a:off x="3749039" y="6583680"/>
+            <a:ext cx="1879092" cy="411480"/>
+          </a:xfrm>
+          <a:prstGeom prst="rect">
+            <a:avLst/>
+          </a:prstGeom>
+          <a:solidFill>
+            <a:srgbClr val="E0D8CC"/>
+          </a:solidFill>
+          <a:ln>
+            <a:noFill/>
+          </a:ln>
+        </p:spPr>
+        <p:style>
+          <a:lnRef idx="1">
+            <a:schemeClr val="accent1"/>
+          </a:lnRef>
+          <a:fillRef idx="3">
+            <a:schemeClr val="accent1"/>
+          </a:fillRef>
+          <a:effectRef idx="2">
+            <a:schemeClr val="accent1"/>
+          </a:effectRef>
+          <a:fontRef idx="minor">
+            <a:schemeClr val="lt1"/>
+          </a:fontRef>
+        </p:style>
+        <p:txBody>
+          <a:bodyPr rtlCol="0" anchor="ctr"/>
+          <a:lstStyle/>
+          <a:p>
+            <a:pPr algn="ctr"/>
+          </a:p>
+        </p:txBody>
+      </p:sp>
+      <p:sp>
+        <p:nvSpPr>
+          <p:cNvPr id="32" name="TextBox 31"/>
+          <p:cNvSpPr txBox="1"/>
+          <p:nvPr/>
+        </p:nvSpPr>
+        <p:spPr>
+          <a:xfrm>
+            <a:off x="3840479" y="6647688"/>
+            <a:ext cx="1696212" cy="320040"/>
+          </a:xfrm>
+          <a:prstGeom prst="rect">
+            <a:avLst/>
+          </a:prstGeom>
+          <a:noFill/>
+        </p:spPr>
+        <p:txBody>
+          <a:bodyPr wrap="square">
+            <a:spAutoFit/>
+          </a:bodyPr>
+          <a:lstStyle/>
+          <a:p>
+            <a:r>
+              <a:rPr sz="1200" b="0">
+                <a:solidFill>
+                  <a:srgbClr val="3D3833"/>
+                </a:solidFill>
+                <a:latin typeface="Courier New"/>
+              </a:rPr>
+              <a:t>Search Intent</a:t>
+            </a:r>
+          </a:p>
+        </p:txBody>
+      </p:sp>
+      <p:sp>
+        <p:nvSpPr>
+          <p:cNvPr id="33" name="Rectangle 32"/>
+          <p:cNvSpPr/>
+          <p:nvPr/>
+        </p:nvSpPr>
+        <p:spPr>
+          <a:xfrm>
+            <a:off x="6492240" y="6583680"/>
+            <a:ext cx="1632204" cy="411480"/>
+          </a:xfrm>
+          <a:prstGeom prst="rect">
+            <a:avLst/>
+          </a:prstGeom>
+          <a:solidFill>
+            <a:srgbClr val="E0D8CC"/>
+          </a:solidFill>
+          <a:ln>
+            <a:noFill/>
+          </a:ln>
+        </p:spPr>
+        <p:style>
+          <a:lnRef idx="1">
+            <a:schemeClr val="accent1"/>
+          </a:lnRef>
+          <a:fillRef idx="3">
+            <a:schemeClr val="accent1"/>
+          </a:fillRef>
+          <a:effectRef idx="2">
+            <a:schemeClr val="accent1"/>
+          </a:effectRef>
+          <a:fontRef idx="minor">
+            <a:schemeClr val="lt1"/>
+          </a:fontRef>
+        </p:style>
+        <p:txBody>
+          <a:bodyPr rtlCol="0" anchor="ctr"/>
+          <a:lstStyle/>
+          <a:p>
+            <a:pPr algn="ctr"/>
+          </a:p>
+        </p:txBody>
+      </p:sp>
+      <p:sp>
+        <p:nvSpPr>
+          <p:cNvPr id="34" name="TextBox 33"/>
+          <p:cNvSpPr txBox="1"/>
+          <p:nvPr/>
+        </p:nvSpPr>
+        <p:spPr>
+          <a:xfrm>
+            <a:off x="6583679" y="6647688"/>
+            <a:ext cx="1449324" cy="320040"/>
+          </a:xfrm>
+          <a:prstGeom prst="rect">
+            <a:avLst/>
+          </a:prstGeom>
+          <a:noFill/>
+        </p:spPr>
+        <p:txBody>
+          <a:bodyPr wrap="square">
+            <a:spAutoFit/>
+          </a:bodyPr>
+          <a:lstStyle/>
+          <a:p>
+            <a:r>
+              <a:rPr sz="1200" b="0">
+                <a:solidFill>
+                  <a:srgbClr val="3D3833"/>
+                </a:solidFill>
+                <a:latin typeface="Courier New"/>
+              </a:rPr>
+              <a:t>Survey CAWI</a:t>
+            </a:r>
+          </a:p>
+        </p:txBody>
+      </p:sp>
+      <p:sp>
+        <p:nvSpPr>
+          <p:cNvPr id="35" name="Rectangle 34"/>
+          <p:cNvSpPr/>
+          <p:nvPr/>
+        </p:nvSpPr>
+        <p:spPr>
+          <a:xfrm>
+            <a:off x="9144000" y="6583680"/>
+            <a:ext cx="644652" cy="411480"/>
+          </a:xfrm>
+          <a:prstGeom prst="rect">
+            <a:avLst/>
+          </a:prstGeom>
+          <a:solidFill>
+            <a:srgbClr val="E0D8CC"/>
+          </a:solidFill>
+          <a:ln>
+            <a:noFill/>
+          </a:ln>
+        </p:spPr>
+        <p:style>
+          <a:lnRef idx="1">
+            <a:schemeClr val="accent1"/>
+          </a:lnRef>
+          <a:fillRef idx="3">
+            <a:schemeClr val="accent1"/>
+          </a:fillRef>
+          <a:effectRef idx="2">
+            <a:schemeClr val="accent1"/>
+          </a:effectRef>
+          <a:fontRef idx="minor">
+            <a:schemeClr val="lt1"/>
+          </a:fontRef>
+        </p:style>
+        <p:txBody>
+          <a:bodyPr rtlCol="0" anchor="ctr"/>
+          <a:lstStyle/>
+          <a:p>
+            <a:pPr algn="ctr"/>
+          </a:p>
+        </p:txBody>
+      </p:sp>
+      <p:sp>
+        <p:nvSpPr>
+          <p:cNvPr id="36" name="TextBox 35"/>
+          <p:cNvSpPr txBox="1"/>
+          <p:nvPr/>
+        </p:nvSpPr>
+        <p:spPr>
+          <a:xfrm>
+            <a:off x="9235440" y="6647688"/>
+            <a:ext cx="461772" cy="320040"/>
+          </a:xfrm>
+          <a:prstGeom prst="rect">
+            <a:avLst/>
+          </a:prstGeom>
+          <a:noFill/>
+        </p:spPr>
+        <p:txBody>
+          <a:bodyPr wrap="square">
+            <a:spAutoFit/>
+          </a:bodyPr>
+          <a:lstStyle/>
+          <a:p>
+            <a:r>
+              <a:rPr sz="1200" b="0">
+                <a:solidFill>
+                  <a:srgbClr val="3D3833"/>
+                </a:solidFill>
+                <a:latin typeface="Courier New"/>
+              </a:rPr>
+              <a:t>CRM</a:t>
+            </a:r>
+          </a:p>
+        </p:txBody>
+      </p:sp>
+      <p:sp>
+        <p:nvSpPr>
+          <p:cNvPr id="37" name="Rectangle 36"/>
+          <p:cNvSpPr/>
+          <p:nvPr/>
+        </p:nvSpPr>
+        <p:spPr>
+          <a:xfrm>
+            <a:off x="10332720" y="6583680"/>
+            <a:ext cx="1879092" cy="411480"/>
+          </a:xfrm>
+          <a:prstGeom prst="rect">
+            <a:avLst/>
+          </a:prstGeom>
+          <a:solidFill>
+            <a:srgbClr val="E0D8CC"/>
+          </a:solidFill>
+          <a:ln>
+            <a:noFill/>
+          </a:ln>
+        </p:spPr>
+        <p:style>
+          <a:lnRef idx="1">
+            <a:schemeClr val="accent1"/>
+          </a:lnRef>
+          <a:fillRef idx="3">
+            <a:schemeClr val="accent1"/>
+          </a:fillRef>
+          <a:effectRef idx="2">
+            <a:schemeClr val="accent1"/>
+          </a:effectRef>
+          <a:fontRef idx="minor">
+            <a:schemeClr val="lt1"/>
+          </a:fontRef>
+        </p:style>
+        <p:txBody>
+          <a:bodyPr rtlCol="0" anchor="ctr"/>
+          <a:lstStyle/>
+          <a:p>
+            <a:pPr algn="ctr"/>
+          </a:p>
+        </p:txBody>
+      </p:sp>
+      <p:sp>
+        <p:nvSpPr>
+          <p:cNvPr id="38" name="TextBox 37"/>
+          <p:cNvSpPr txBox="1"/>
+          <p:nvPr/>
+        </p:nvSpPr>
+        <p:spPr>
+          <a:xfrm>
+            <a:off x="10424160" y="6647688"/>
+            <a:ext cx="1696212" cy="320040"/>
+          </a:xfrm>
+          <a:prstGeom prst="rect">
+            <a:avLst/>
+          </a:prstGeom>
+          <a:noFill/>
+        </p:spPr>
+        <p:txBody>
+          <a:bodyPr wrap="square">
+            <a:spAutoFit/>
+          </a:bodyPr>
+          <a:lstStyle/>
+          <a:p>
+            <a:r>
+              <a:rPr sz="1200" b="0">
+                <a:solidFill>
+                  <a:srgbClr val="3D3833"/>
+                </a:solidFill>
+                <a:latin typeface="Courier New"/>
+              </a:rPr>
+              <a:t>Web Analytics</a:t>
+            </a:r>
+          </a:p>
+        </p:txBody>
+      </p:sp>
+      <p:sp>
+        <p:nvSpPr>
+          <p:cNvPr id="39" name="Rectangle 38"/>
+          <p:cNvSpPr/>
+          <p:nvPr/>
+        </p:nvSpPr>
+        <p:spPr>
+          <a:xfrm>
+            <a:off x="12801600" y="6583680"/>
+            <a:ext cx="1138428" cy="411480"/>
+          </a:xfrm>
+          <a:prstGeom prst="rect">
+            <a:avLst/>
+          </a:prstGeom>
+          <a:solidFill>
+            <a:srgbClr val="E0D8CC"/>
+          </a:solidFill>
+          <a:ln>
+            <a:noFill/>
+          </a:ln>
+        </p:spPr>
+        <p:style>
+          <a:lnRef idx="1">
+            <a:schemeClr val="accent1"/>
+          </a:lnRef>
+          <a:fillRef idx="3">
+            <a:schemeClr val="accent1"/>
+          </a:fillRef>
+          <a:effectRef idx="2">
+            <a:schemeClr val="accent1"/>
+          </a:effectRef>
+          <a:fontRef idx="minor">
+            <a:schemeClr val="lt1"/>
+          </a:fontRef>
+        </p:style>
+        <p:txBody>
+          <a:bodyPr rtlCol="0" anchor="ctr"/>
+          <a:lstStyle/>
+          <a:p>
+            <a:pPr algn="ctr"/>
+          </a:p>
+        </p:txBody>
+      </p:sp>
+      <p:sp>
+        <p:nvSpPr>
+          <p:cNvPr id="40" name="TextBox 39"/>
+          <p:cNvSpPr txBox="1"/>
+          <p:nvPr/>
+        </p:nvSpPr>
+        <p:spPr>
+          <a:xfrm>
+            <a:off x="12893040" y="6647688"/>
+            <a:ext cx="955548" cy="320040"/>
+          </a:xfrm>
+          <a:prstGeom prst="rect">
+            <a:avLst/>
+          </a:prstGeom>
+          <a:noFill/>
+        </p:spPr>
+        <p:txBody>
+          <a:bodyPr wrap="square">
+            <a:spAutoFit/>
+          </a:bodyPr>
+          <a:lstStyle/>
+          <a:p>
+            <a:r>
+              <a:rPr sz="1200" b="0">
+                <a:solidFill>
+                  <a:srgbClr val="3D3833"/>
+                </a:solidFill>
+                <a:latin typeface="Courier New"/>
+              </a:rPr>
+              <a:t>Reviews</a:t>
+            </a:r>
+          </a:p>
+        </p:txBody>
+      </p:sp>
+      <p:sp>
+        <p:nvSpPr>
+          <p:cNvPr id="41" name="Rectangle 40"/>
+          <p:cNvSpPr/>
+          <p:nvPr/>
+        </p:nvSpPr>
+        <p:spPr>
+          <a:xfrm>
+            <a:off x="14447520" y="6583680"/>
+            <a:ext cx="1261872" cy="411480"/>
+          </a:xfrm>
+          <a:prstGeom prst="rect">
+            <a:avLst/>
+          </a:prstGeom>
+          <a:solidFill>
+            <a:srgbClr val="E0D8CC"/>
+          </a:solidFill>
+          <a:ln>
+            <a:noFill/>
+          </a:ln>
+        </p:spPr>
+        <p:style>
+          <a:lnRef idx="1">
+            <a:schemeClr val="accent1"/>
+          </a:lnRef>
+          <a:fillRef idx="3">
+            <a:schemeClr val="accent1"/>
+          </a:fillRef>
+          <a:effectRef idx="2">
+            <a:schemeClr val="accent1"/>
+          </a:effectRef>
+          <a:fontRef idx="minor">
+            <a:schemeClr val="lt1"/>
+          </a:fontRef>
+        </p:style>
+        <p:txBody>
+          <a:bodyPr rtlCol="0" anchor="ctr"/>
+          <a:lstStyle/>
+          <a:p>
+            <a:pPr algn="ctr"/>
+          </a:p>
+        </p:txBody>
+      </p:sp>
+      <p:sp>
+        <p:nvSpPr>
+          <p:cNvPr id="42" name="TextBox 41"/>
+          <p:cNvSpPr txBox="1"/>
+          <p:nvPr/>
+        </p:nvSpPr>
+        <p:spPr>
+          <a:xfrm>
+            <a:off x="14538960" y="6647688"/>
+            <a:ext cx="1078992" cy="320040"/>
+          </a:xfrm>
+          <a:prstGeom prst="rect">
+            <a:avLst/>
+          </a:prstGeom>
+          <a:noFill/>
+        </p:spPr>
+        <p:txBody>
+          <a:bodyPr wrap="square">
+            <a:spAutoFit/>
+          </a:bodyPr>
+          <a:lstStyle/>
+          <a:p>
+            <a:r>
+              <a:rPr sz="1200" b="0">
+                <a:solidFill>
+                  <a:srgbClr val="3D3833"/>
+                </a:solidFill>
+                <a:latin typeface="Courier New"/>
+              </a:rPr>
+              <a:t>GEO &amp; AI</a:t>
+            </a:r>
+          </a:p>
+        </p:txBody>
+      </p:sp>
+      <p:sp>
+        <p:nvSpPr>
+          <p:cNvPr id="43" name="TextBox 42"/>
+          <p:cNvSpPr txBox="1"/>
+          <p:nvPr/>
+        </p:nvSpPr>
+        <p:spPr>
+          <a:xfrm>
+            <a:off x="914400" y="7406640"/>
+            <a:ext cx="15544800" cy="548640"/>
+          </a:xfrm>
+          <a:prstGeom prst="rect">
+            <a:avLst/>
+          </a:prstGeom>
+          <a:noFill/>
+        </p:spPr>
+        <p:txBody>
+          <a:bodyPr wrap="square">
+            <a:spAutoFit/>
+          </a:bodyPr>
+          <a:lstStyle/>
+          <a:p>
+            <a:r>
+              <a:rPr sz="1700" b="0">
+                <a:solidFill>
+                  <a:srgbClr val="B8523A"/>
+                </a:solidFill>
+                <a:latin typeface="Arial"/>
+              </a:rPr>
+              <a:t>Il professionista maturo non difende una fonte: sceglie quella giusta per la domanda giusta.</a:t>
+            </a:r>
+          </a:p>
+        </p:txBody>
+      </p:sp>
+      <p:sp>
+        <p:nvSpPr>
+          <p:cNvPr id="44" name="TextBox 43"/>
+          <p:cNvSpPr txBox="1"/>
+          <p:nvPr/>
+        </p:nvSpPr>
+        <p:spPr>
+          <a:xfrm>
+            <a:off x="914400" y="8321040"/>
+            <a:ext cx="15544800" cy="640080"/>
+          </a:xfrm>
+          <a:prstGeom prst="rect">
+            <a:avLst/>
+          </a:prstGeom>
+          <a:noFill/>
+        </p:spPr>
+        <p:txBody>
+          <a:bodyPr wrap="square">
+            <a:spAutoFit/>
+          </a:bodyPr>
+          <a:lstStyle/>
+          <a:p>
+            <a:r>
+              <a:rPr sz="1200" b="0">
+                <a:solidFill>
+                  <a:srgbClr val="8A8175"/>
+                </a:solidFill>
+                <a:latin typeface="Courier New"/>
+              </a:rPr>
+              <a:t>NOTA RELATORE: "Questo e il modo in cui lavoro ogni giorno. La differenza tra chi produce report e chi produce decisioni passa da questo schema."</a:t>
+            </a:r>
+          </a:p>
+        </p:txBody>
+      </p:sp>
+    </p:spTree>
+  </p:cSld>
+  <p:clrMapOvr>
+    <a:masterClrMapping/>
+  </p:clrMapOvr>
+</p:sld>
+</file>
+
+<file path=ppt/slides/slide35.xml><?xml version="1.0" encoding="utf-8"?>
+<p:sld xmlns:a="http://schemas.openxmlformats.org/drawingml/2006/main" xmlns:p="http://schemas.openxmlformats.org/presentationml/2006/main" xmlns:r="http://schemas.openxmlformats.org/officeDocument/2006/relationships">
+  <p:cSld>
+    <p:bg>
+      <p:bgPr>
+        <a:solidFill>
+          <a:srgbClr val="F3EDE1"/>
+        </a:solidFill>
+        <a:effectLst/>
+      </p:bgPr>
+    </p:bg>
+    <p:spTree>
+      <p:nvGrpSpPr>
+        <p:cNvPr id="1" name=""/>
+        <p:cNvGrpSpPr/>
+        <p:nvPr/>
+      </p:nvGrpSpPr>
+      <p:grpSpPr/>
+      <p:sp>
+        <p:nvSpPr>
+          <p:cNvPr id="2" name="TextBox 1"/>
+          <p:cNvSpPr txBox="1"/>
+          <p:nvPr/>
+        </p:nvSpPr>
+        <p:spPr>
+          <a:xfrm>
+            <a:off x="914400" y="914400"/>
+            <a:ext cx="16459200" cy="365760"/>
+          </a:xfrm>
+          <a:prstGeom prst="rect">
+            <a:avLst/>
+          </a:prstGeom>
+          <a:noFill/>
+        </p:spPr>
+        <p:txBody>
+          <a:bodyPr wrap="none">
+            <a:spAutoFit/>
+          </a:bodyPr>
+          <a:lstStyle/>
+          <a:p>
+            <a:r>
+              <a:rPr sz="1800">
+                <a:solidFill>
+                  <a:srgbClr val="B8523A"/>
+                </a:solidFill>
+                <a:latin typeface="Courier New"/>
+              </a:rPr>
+              <a:t>● </a:t>
+            </a:r>
+            <a:r>
+              <a:rPr sz="1800">
+                <a:solidFill>
+                  <a:srgbClr val="8A8175"/>
+                </a:solidFill>
+                <a:latin typeface="Courier New"/>
+              </a:rPr>
+              <a:t>UNA MAPPA, NON UNA SCELTA</a:t>
+            </a:r>
+          </a:p>
+        </p:txBody>
+      </p:sp>
+      <p:sp>
+        <p:nvSpPr>
+          <p:cNvPr id="3" name="TextBox 2"/>
+          <p:cNvSpPr txBox="1"/>
+          <p:nvPr/>
+        </p:nvSpPr>
+        <p:spPr>
+          <a:xfrm>
+            <a:off x="914400" y="1371600"/>
+            <a:ext cx="15544800" cy="1097280"/>
+          </a:xfrm>
+          <a:prstGeom prst="rect">
+            <a:avLst/>
+          </a:prstGeom>
+          <a:noFill/>
+        </p:spPr>
+        <p:txBody>
+          <a:bodyPr wrap="square">
+            <a:spAutoFit/>
+          </a:bodyPr>
+          <a:lstStyle/>
+          <a:p>
+            <a:r>
+              <a:rPr sz="3800">
+                <a:solidFill>
+                  <a:srgbClr val="1A1714"/>
+                </a:solidFill>
+                <a:latin typeface="Georgia"/>
+              </a:rPr>
+              <a:t>Non difendere una fonte. </a:t>
+            </a:r>
+            <a:r>
+              <a:rPr sz="3800">
+                <a:solidFill>
+                  <a:srgbClr val="B8523A"/>
+                </a:solidFill>
+                <a:latin typeface="Georgia"/>
+              </a:rPr>
+              <a:t>Scegliere quella giusta per la domanda giusta.</a:t>
+            </a:r>
+          </a:p>
+        </p:txBody>
+      </p:sp>
+      <p:sp>
+        <p:nvSpPr>
+          <p:cNvPr id="4" name="Rectangle 3"/>
+          <p:cNvSpPr/>
+          <p:nvPr/>
+        </p:nvSpPr>
+        <p:spPr>
+          <a:xfrm>
+            <a:off x="320040" y="2926080"/>
+            <a:ext cx="3246120" cy="1481328"/>
+          </a:xfrm>
+          <a:prstGeom prst="rect">
+            <a:avLst/>
+          </a:prstGeom>
+          <a:solidFill>
+            <a:srgbClr val="B8523A"/>
+          </a:solidFill>
+          <a:ln>
+            <a:noFill/>
+          </a:ln>
+        </p:spPr>
+        <p:style>
+          <a:lnRef idx="1">
+            <a:schemeClr val="accent1"/>
+          </a:lnRef>
+          <a:fillRef idx="3">
+            <a:schemeClr val="accent1"/>
+          </a:fillRef>
+          <a:effectRef idx="2">
+            <a:schemeClr val="accent1"/>
+          </a:effectRef>
+          <a:fontRef idx="minor">
+            <a:schemeClr val="lt1"/>
+          </a:fontRef>
+        </p:style>
+        <p:txBody>
+          <a:bodyPr rtlCol="0" anchor="ctr"/>
+          <a:lstStyle/>
+          <a:p>
+            <a:pPr algn="ctr"/>
+          </a:p>
+        </p:txBody>
+      </p:sp>
+      <p:sp>
+        <p:nvSpPr>
+          <p:cNvPr id="5" name="TextBox 4"/>
+          <p:cNvSpPr txBox="1"/>
+          <p:nvPr/>
+        </p:nvSpPr>
+        <p:spPr>
+          <a:xfrm>
+            <a:off x="429768" y="3017520"/>
+            <a:ext cx="3063239" cy="320040"/>
+          </a:xfrm>
+          <a:prstGeom prst="rect">
+            <a:avLst/>
+          </a:prstGeom>
+          <a:noFill/>
+        </p:spPr>
+        <p:txBody>
+          <a:bodyPr wrap="square">
+            <a:spAutoFit/>
+          </a:bodyPr>
+          <a:lstStyle/>
+          <a:p>
+            <a:r>
+              <a:rPr sz="1000" b="0">
+                <a:solidFill>
+                  <a:srgbClr val="EBE4D3"/>
+                </a:solidFill>
+                <a:latin typeface="Courier New"/>
+              </a:rPr>
+              <a:t>VOCE SPONTANEA</a:t>
+            </a:r>
+          </a:p>
+        </p:txBody>
+      </p:sp>
+      <p:sp>
+        <p:nvSpPr>
+          <p:cNvPr id="6" name="TextBox 5"/>
+          <p:cNvSpPr txBox="1"/>
+          <p:nvPr/>
+        </p:nvSpPr>
+        <p:spPr>
+          <a:xfrm>
+            <a:off x="429768" y="3383280"/>
+            <a:ext cx="3063239" cy="685800"/>
+          </a:xfrm>
+          <a:prstGeom prst="rect">
+            <a:avLst/>
+          </a:prstGeom>
+          <a:noFill/>
+        </p:spPr>
+        <p:txBody>
+          <a:bodyPr wrap="square">
+            <a:spAutoFit/>
+          </a:bodyPr>
+          <a:lstStyle/>
+          <a:p>
+            <a:r>
+              <a:rPr sz="1900" b="1">
+                <a:solidFill>
+                  <a:srgbClr val="F3EDE1"/>
+                </a:solidFill>
+                <a:latin typeface="Georgia"/>
+              </a:rPr>
+              <a:t>Social Listening</a:t>
+            </a:r>
+          </a:p>
+        </p:txBody>
+      </p:sp>
+      <p:sp>
+        <p:nvSpPr>
+          <p:cNvPr id="7" name="Rectangle 6"/>
+          <p:cNvSpPr/>
+          <p:nvPr/>
+        </p:nvSpPr>
+        <p:spPr>
+          <a:xfrm>
+            <a:off x="3657600" y="2926080"/>
+            <a:ext cx="3246120" cy="1481328"/>
+          </a:xfrm>
+          <a:prstGeom prst="rect">
+            <a:avLst/>
+          </a:prstGeom>
+          <a:solidFill>
+            <a:srgbClr val="4A7262"/>
+          </a:solidFill>
+          <a:ln>
+            <a:noFill/>
+          </a:ln>
+        </p:spPr>
+        <p:style>
+          <a:lnRef idx="1">
+            <a:schemeClr val="accent1"/>
+          </a:lnRef>
+          <a:fillRef idx="3">
+            <a:schemeClr val="accent1"/>
+          </a:fillRef>
+          <a:effectRef idx="2">
+            <a:schemeClr val="accent1"/>
+          </a:effectRef>
+          <a:fontRef idx="minor">
+            <a:schemeClr val="lt1"/>
+          </a:fontRef>
+        </p:style>
+        <p:txBody>
+          <a:bodyPr rtlCol="0" anchor="ctr"/>
+          <a:lstStyle/>
+          <a:p>
+            <a:pPr algn="ctr"/>
+          </a:p>
+        </p:txBody>
+      </p:sp>
+      <p:sp>
+        <p:nvSpPr>
+          <p:cNvPr id="8" name="TextBox 7"/>
+          <p:cNvSpPr txBox="1"/>
+          <p:nvPr/>
+        </p:nvSpPr>
+        <p:spPr>
+          <a:xfrm>
+            <a:off x="3767328" y="3017520"/>
+            <a:ext cx="3063239" cy="320040"/>
+          </a:xfrm>
+          <a:prstGeom prst="rect">
+            <a:avLst/>
+          </a:prstGeom>
+          <a:noFill/>
+        </p:spPr>
+        <p:txBody>
+          <a:bodyPr wrap="square">
+            <a:spAutoFit/>
+          </a:bodyPr>
+          <a:lstStyle/>
+          <a:p>
+            <a:r>
+              <a:rPr sz="1000" b="0">
+                <a:solidFill>
+                  <a:srgbClr val="EBE4D3"/>
+                </a:solidFill>
+                <a:latin typeface="Courier New"/>
+              </a:rPr>
+              <a:t>VOCE SOLLECITATA</a:t>
+            </a:r>
+          </a:p>
+        </p:txBody>
+      </p:sp>
+      <p:sp>
+        <p:nvSpPr>
+          <p:cNvPr id="9" name="TextBox 8"/>
+          <p:cNvSpPr txBox="1"/>
+          <p:nvPr/>
+        </p:nvSpPr>
+        <p:spPr>
+          <a:xfrm>
+            <a:off x="3767328" y="3383280"/>
+            <a:ext cx="3063239" cy="685800"/>
+          </a:xfrm>
+          <a:prstGeom prst="rect">
+            <a:avLst/>
+          </a:prstGeom>
+          <a:noFill/>
+        </p:spPr>
+        <p:txBody>
+          <a:bodyPr wrap="square">
+            <a:spAutoFit/>
+          </a:bodyPr>
+          <a:lstStyle/>
+          <a:p>
+            <a:r>
+              <a:rPr sz="1900" b="1">
+                <a:solidFill>
+                  <a:srgbClr val="F3EDE1"/>
+                </a:solidFill>
+                <a:latin typeface="Georgia"/>
+              </a:rPr>
+              <a:t>Survey CAWI</a:t>
+            </a:r>
+          </a:p>
+        </p:txBody>
+      </p:sp>
+      <p:sp>
+        <p:nvSpPr>
+          <p:cNvPr id="10" name="Rectangle 9"/>
+          <p:cNvSpPr/>
+          <p:nvPr/>
+        </p:nvSpPr>
+        <p:spPr>
+          <a:xfrm>
+            <a:off x="6995159" y="2926080"/>
+            <a:ext cx="3246120" cy="1481328"/>
+          </a:xfrm>
+          <a:prstGeom prst="rect">
+            <a:avLst/>
+          </a:prstGeom>
+          <a:solidFill>
+            <a:srgbClr val="3A5A7A"/>
+          </a:solidFill>
+          <a:ln>
+            <a:noFill/>
+          </a:ln>
+        </p:spPr>
+        <p:style>
+          <a:lnRef idx="1">
+            <a:schemeClr val="accent1"/>
+          </a:lnRef>
+          <a:fillRef idx="3">
+            <a:schemeClr val="accent1"/>
+          </a:fillRef>
+          <a:effectRef idx="2">
+            <a:schemeClr val="accent1"/>
+          </a:effectRef>
+          <a:fontRef idx="minor">
+            <a:schemeClr val="lt1"/>
+          </a:fontRef>
+        </p:style>
+        <p:txBody>
+          <a:bodyPr rtlCol="0" anchor="ctr"/>
+          <a:lstStyle/>
+          <a:p>
+            <a:pPr algn="ctr"/>
+          </a:p>
+        </p:txBody>
+      </p:sp>
+      <p:sp>
+        <p:nvSpPr>
+          <p:cNvPr id="11" name="TextBox 10"/>
+          <p:cNvSpPr txBox="1"/>
+          <p:nvPr/>
+        </p:nvSpPr>
+        <p:spPr>
+          <a:xfrm>
+            <a:off x="7104888" y="3017520"/>
+            <a:ext cx="3063239" cy="320040"/>
+          </a:xfrm>
+          <a:prstGeom prst="rect">
+            <a:avLst/>
+          </a:prstGeom>
+          <a:noFill/>
+        </p:spPr>
+        <p:txBody>
+          <a:bodyPr wrap="square">
+            <a:spAutoFit/>
+          </a:bodyPr>
+          <a:lstStyle/>
+          <a:p>
+            <a:r>
+              <a:rPr sz="1000" b="0">
+                <a:solidFill>
+                  <a:srgbClr val="EBE4D3"/>
+                </a:solidFill>
+                <a:latin typeface="Courier New"/>
+              </a:rPr>
+              <a:t>ESPERIENZA</a:t>
+            </a:r>
+          </a:p>
+        </p:txBody>
+      </p:sp>
+      <p:sp>
+        <p:nvSpPr>
+          <p:cNvPr id="12" name="TextBox 11"/>
+          <p:cNvSpPr txBox="1"/>
+          <p:nvPr/>
+        </p:nvSpPr>
+        <p:spPr>
+          <a:xfrm>
+            <a:off x="7104888" y="3383280"/>
+            <a:ext cx="3063239" cy="685800"/>
+          </a:xfrm>
+          <a:prstGeom prst="rect">
+            <a:avLst/>
+          </a:prstGeom>
+          <a:noFill/>
+        </p:spPr>
+        <p:txBody>
+          <a:bodyPr wrap="square">
+            <a:spAutoFit/>
+          </a:bodyPr>
+          <a:lstStyle/>
+          <a:p>
+            <a:r>
+              <a:rPr sz="1900" b="1">
+                <a:solidFill>
+                  <a:srgbClr val="F3EDE1"/>
+                </a:solidFill>
+                <a:latin typeface="Georgia"/>
+              </a:rPr>
+              <a:t>NPS / CSAT</a:t>
+            </a:r>
+          </a:p>
+        </p:txBody>
+      </p:sp>
+      <p:sp>
+        <p:nvSpPr>
+          <p:cNvPr id="13" name="Rectangle 12"/>
+          <p:cNvSpPr/>
+          <p:nvPr/>
+        </p:nvSpPr>
+        <p:spPr>
+          <a:xfrm>
+            <a:off x="10332719" y="2926080"/>
+            <a:ext cx="3246120" cy="1481328"/>
+          </a:xfrm>
+          <a:prstGeom prst="rect">
+            <a:avLst/>
+          </a:prstGeom>
+          <a:solidFill>
+            <a:srgbClr val="5A4A6A"/>
+          </a:solidFill>
+          <a:ln>
+            <a:noFill/>
+          </a:ln>
+        </p:spPr>
+        <p:style>
+          <a:lnRef idx="1">
+            <a:schemeClr val="accent1"/>
+          </a:lnRef>
+          <a:fillRef idx="3">
+            <a:schemeClr val="accent1"/>
+          </a:fillRef>
+          <a:effectRef idx="2">
+            <a:schemeClr val="accent1"/>
+          </a:effectRef>
+          <a:fontRef idx="minor">
+            <a:schemeClr val="lt1"/>
+          </a:fontRef>
+        </p:style>
+        <p:txBody>
+          <a:bodyPr rtlCol="0" anchor="ctr"/>
+          <a:lstStyle/>
+          <a:p>
+            <a:pPr algn="ctr"/>
+          </a:p>
+        </p:txBody>
+      </p:sp>
+      <p:sp>
+        <p:nvSpPr>
+          <p:cNvPr id="14" name="TextBox 13"/>
+          <p:cNvSpPr txBox="1"/>
+          <p:nvPr/>
+        </p:nvSpPr>
+        <p:spPr>
+          <a:xfrm>
+            <a:off x="10442447" y="3017520"/>
+            <a:ext cx="3063239" cy="320040"/>
+          </a:xfrm>
+          <a:prstGeom prst="rect">
+            <a:avLst/>
+          </a:prstGeom>
+          <a:noFill/>
+        </p:spPr>
+        <p:txBody>
+          <a:bodyPr wrap="square">
+            <a:spAutoFit/>
+          </a:bodyPr>
+          <a:lstStyle/>
+          <a:p>
+            <a:r>
+              <a:rPr sz="1000" b="0">
+                <a:solidFill>
+                  <a:srgbClr val="EBE4D3"/>
+                </a:solidFill>
+                <a:latin typeface="Courier New"/>
+              </a:rPr>
+              <a:t>PERCEZIONE</a:t>
+            </a:r>
+          </a:p>
+        </p:txBody>
+      </p:sp>
+      <p:sp>
+        <p:nvSpPr>
+          <p:cNvPr id="15" name="TextBox 14"/>
+          <p:cNvSpPr txBox="1"/>
+          <p:nvPr/>
+        </p:nvSpPr>
+        <p:spPr>
+          <a:xfrm>
+            <a:off x="10442447" y="3383280"/>
+            <a:ext cx="3063239" cy="685800"/>
+          </a:xfrm>
+          <a:prstGeom prst="rect">
+            <a:avLst/>
+          </a:prstGeom>
+          <a:noFill/>
+        </p:spPr>
+        <p:txBody>
+          <a:bodyPr wrap="square">
+            <a:spAutoFit/>
+          </a:bodyPr>
+          <a:lstStyle/>
+          <a:p>
+            <a:r>
+              <a:rPr sz="1900" b="1">
+                <a:solidFill>
+                  <a:srgbClr val="F3EDE1"/>
+                </a:solidFill>
+                <a:latin typeface="Georgia"/>
+              </a:rPr>
+              <a:t>Brand Tracking</a:t>
+            </a:r>
+          </a:p>
+        </p:txBody>
+      </p:sp>
+      <p:sp>
+        <p:nvSpPr>
+          <p:cNvPr id="16" name="Rectangle 15"/>
+          <p:cNvSpPr/>
+          <p:nvPr/>
+        </p:nvSpPr>
+        <p:spPr>
+          <a:xfrm>
+            <a:off x="13670280" y="2926080"/>
+            <a:ext cx="3246120" cy="1481328"/>
+          </a:xfrm>
+          <a:prstGeom prst="rect">
+            <a:avLst/>
+          </a:prstGeom>
+          <a:solidFill>
+            <a:srgbClr val="6A583A"/>
+          </a:solidFill>
+          <a:ln>
+            <a:noFill/>
+          </a:ln>
+        </p:spPr>
+        <p:style>
+          <a:lnRef idx="1">
+            <a:schemeClr val="accent1"/>
+          </a:lnRef>
+          <a:fillRef idx="3">
+            <a:schemeClr val="accent1"/>
+          </a:fillRef>
+          <a:effectRef idx="2">
+            <a:schemeClr val="accent1"/>
+          </a:effectRef>
+          <a:fontRef idx="minor">
+            <a:schemeClr val="lt1"/>
+          </a:fontRef>
+        </p:style>
+        <p:txBody>
+          <a:bodyPr rtlCol="0" anchor="ctr"/>
+          <a:lstStyle/>
+          <a:p>
+            <a:pPr algn="ctr"/>
+          </a:p>
+        </p:txBody>
+      </p:sp>
+      <p:sp>
+        <p:nvSpPr>
+          <p:cNvPr id="17" name="TextBox 16"/>
+          <p:cNvSpPr txBox="1"/>
+          <p:nvPr/>
+        </p:nvSpPr>
+        <p:spPr>
+          <a:xfrm>
+            <a:off x="13780007" y="3017520"/>
+            <a:ext cx="3063239" cy="320040"/>
+          </a:xfrm>
+          <a:prstGeom prst="rect">
+            <a:avLst/>
+          </a:prstGeom>
+          <a:noFill/>
+        </p:spPr>
+        <p:txBody>
+          <a:bodyPr wrap="square">
+            <a:spAutoFit/>
+          </a:bodyPr>
+          <a:lstStyle/>
+          <a:p>
+            <a:r>
+              <a:rPr sz="1000" b="0">
+                <a:solidFill>
+                  <a:srgbClr val="EBE4D3"/>
+                </a:solidFill>
+                <a:latin typeface="Courier New"/>
+              </a:rPr>
+              <a:t>INTENTO</a:t>
+            </a:r>
+          </a:p>
+        </p:txBody>
+      </p:sp>
+      <p:sp>
+        <p:nvSpPr>
+          <p:cNvPr id="18" name="TextBox 17"/>
+          <p:cNvSpPr txBox="1"/>
+          <p:nvPr/>
+        </p:nvSpPr>
+        <p:spPr>
+          <a:xfrm>
+            <a:off x="13780007" y="3383280"/>
+            <a:ext cx="3063239" cy="685800"/>
+          </a:xfrm>
+          <a:prstGeom prst="rect">
+            <a:avLst/>
+          </a:prstGeom>
+          <a:noFill/>
+        </p:spPr>
+        <p:txBody>
+          <a:bodyPr wrap="square">
+            <a:spAutoFit/>
+          </a:bodyPr>
+          <a:lstStyle/>
+          <a:p>
+            <a:r>
+              <a:rPr sz="1900" b="1">
+                <a:solidFill>
+                  <a:srgbClr val="F3EDE1"/>
+                </a:solidFill>
+                <a:latin typeface="Georgia"/>
+              </a:rPr>
+              <a:t>Search Intent</a:t>
+            </a:r>
+          </a:p>
+        </p:txBody>
+      </p:sp>
+      <p:sp>
+        <p:nvSpPr>
+          <p:cNvPr id="19" name="Rectangle 18"/>
+          <p:cNvSpPr/>
+          <p:nvPr/>
+        </p:nvSpPr>
+        <p:spPr>
+          <a:xfrm>
+            <a:off x="320040" y="4480560"/>
+            <a:ext cx="3246120" cy="1481328"/>
+          </a:xfrm>
+          <a:prstGeom prst="rect">
+            <a:avLst/>
+          </a:prstGeom>
+          <a:solidFill>
+            <a:srgbClr val="4A5A4A"/>
+          </a:solidFill>
+          <a:ln>
+            <a:noFill/>
+          </a:ln>
+        </p:spPr>
+        <p:style>
+          <a:lnRef idx="1">
+            <a:schemeClr val="accent1"/>
+          </a:lnRef>
+          <a:fillRef idx="3">
+            <a:schemeClr val="accent1"/>
+          </a:fillRef>
+          <a:effectRef idx="2">
+            <a:schemeClr val="accent1"/>
+          </a:effectRef>
+          <a:fontRef idx="minor">
+            <a:schemeClr val="lt1"/>
+          </a:fontRef>
+        </p:style>
+        <p:txBody>
+          <a:bodyPr rtlCol="0" anchor="ctr"/>
+          <a:lstStyle/>
+          <a:p>
+            <a:pPr algn="ctr"/>
+          </a:p>
+        </p:txBody>
+      </p:sp>
+      <p:sp>
+        <p:nvSpPr>
+          <p:cNvPr id="20" name="TextBox 19"/>
+          <p:cNvSpPr txBox="1"/>
+          <p:nvPr/>
+        </p:nvSpPr>
+        <p:spPr>
+          <a:xfrm>
+            <a:off x="429768" y="4572000"/>
+            <a:ext cx="3063239" cy="320040"/>
+          </a:xfrm>
+          <a:prstGeom prst="rect">
+            <a:avLst/>
+          </a:prstGeom>
+          <a:noFill/>
+        </p:spPr>
+        <p:txBody>
+          <a:bodyPr wrap="square">
+            <a:spAutoFit/>
+          </a:bodyPr>
+          <a:lstStyle/>
+          <a:p>
+            <a:r>
+              <a:rPr sz="1000" b="0">
+                <a:solidFill>
+                  <a:srgbClr val="EBE4D3"/>
+                </a:solidFill>
+                <a:latin typeface="Courier New"/>
+              </a:rPr>
+              <a:t>COMPORTAMENTO</a:t>
+            </a:r>
+          </a:p>
+        </p:txBody>
+      </p:sp>
+      <p:sp>
+        <p:nvSpPr>
+          <p:cNvPr id="21" name="TextBox 20"/>
+          <p:cNvSpPr txBox="1"/>
+          <p:nvPr/>
+        </p:nvSpPr>
+        <p:spPr>
+          <a:xfrm>
+            <a:off x="429768" y="4937760"/>
+            <a:ext cx="3063239" cy="685800"/>
+          </a:xfrm>
+          <a:prstGeom prst="rect">
+            <a:avLst/>
+          </a:prstGeom>
+          <a:noFill/>
+        </p:spPr>
+        <p:txBody>
+          <a:bodyPr wrap="square">
+            <a:spAutoFit/>
+          </a:bodyPr>
+          <a:lstStyle/>
+          <a:p>
+            <a:r>
+              <a:rPr sz="1900" b="1">
+                <a:solidFill>
+                  <a:srgbClr val="F3EDE1"/>
+                </a:solidFill>
+                <a:latin typeface="Georgia"/>
+              </a:rPr>
+              <a:t>Web Analytics</a:t>
+            </a:r>
+          </a:p>
+        </p:txBody>
+      </p:sp>
+      <p:sp>
+        <p:nvSpPr>
+          <p:cNvPr id="22" name="Rectangle 21"/>
+          <p:cNvSpPr/>
+          <p:nvPr/>
+        </p:nvSpPr>
+        <p:spPr>
+          <a:xfrm>
+            <a:off x="3657600" y="4480560"/>
+            <a:ext cx="3246120" cy="1481328"/>
+          </a:xfrm>
+          <a:prstGeom prst="rect">
+            <a:avLst/>
+          </a:prstGeom>
+          <a:solidFill>
+            <a:srgbClr val="5A3A3A"/>
+          </a:solidFill>
+          <a:ln>
+            <a:noFill/>
+          </a:ln>
+        </p:spPr>
+        <p:style>
+          <a:lnRef idx="1">
+            <a:schemeClr val="accent1"/>
+          </a:lnRef>
+          <a:fillRef idx="3">
+            <a:schemeClr val="accent1"/>
+          </a:fillRef>
+          <a:effectRef idx="2">
+            <a:schemeClr val="accent1"/>
+          </a:effectRef>
+          <a:fontRef idx="minor">
+            <a:schemeClr val="lt1"/>
+          </a:fontRef>
+        </p:style>
+        <p:txBody>
+          <a:bodyPr rtlCol="0" anchor="ctr"/>
+          <a:lstStyle/>
+          <a:p>
+            <a:pPr algn="ctr"/>
+          </a:p>
+        </p:txBody>
+      </p:sp>
+      <p:sp>
+        <p:nvSpPr>
+          <p:cNvPr id="23" name="TextBox 22"/>
+          <p:cNvSpPr txBox="1"/>
+          <p:nvPr/>
+        </p:nvSpPr>
+        <p:spPr>
+          <a:xfrm>
+            <a:off x="3767328" y="4572000"/>
+            <a:ext cx="3063239" cy="320040"/>
+          </a:xfrm>
+          <a:prstGeom prst="rect">
+            <a:avLst/>
+          </a:prstGeom>
+          <a:noFill/>
+        </p:spPr>
+        <p:txBody>
+          <a:bodyPr wrap="square">
+            <a:spAutoFit/>
+          </a:bodyPr>
+          <a:lstStyle/>
+          <a:p>
+            <a:r>
+              <a:rPr sz="1000" b="0">
+                <a:solidFill>
+                  <a:srgbClr val="EBE4D3"/>
+                </a:solidFill>
+                <a:latin typeface="Courier New"/>
+              </a:rPr>
+              <a:t>CUSTOMER BASE</a:t>
+            </a:r>
+          </a:p>
+        </p:txBody>
+      </p:sp>
+      <p:sp>
+        <p:nvSpPr>
+          <p:cNvPr id="24" name="TextBox 23"/>
+          <p:cNvSpPr txBox="1"/>
+          <p:nvPr/>
+        </p:nvSpPr>
+        <p:spPr>
+          <a:xfrm>
+            <a:off x="3767328" y="4937760"/>
+            <a:ext cx="3063239" cy="685800"/>
+          </a:xfrm>
+          <a:prstGeom prst="rect">
+            <a:avLst/>
+          </a:prstGeom>
+          <a:noFill/>
+        </p:spPr>
+        <p:txBody>
+          <a:bodyPr wrap="square">
+            <a:spAutoFit/>
+          </a:bodyPr>
+          <a:lstStyle/>
+          <a:p>
+            <a:r>
+              <a:rPr sz="1900" b="1">
+                <a:solidFill>
+                  <a:srgbClr val="F3EDE1"/>
+                </a:solidFill>
+                <a:latin typeface="Georgia"/>
+              </a:rPr>
+              <a:t>CRM</a:t>
+            </a:r>
+          </a:p>
+        </p:txBody>
+      </p:sp>
+      <p:sp>
+        <p:nvSpPr>
+          <p:cNvPr id="25" name="Rectangle 24"/>
+          <p:cNvSpPr/>
+          <p:nvPr/>
+        </p:nvSpPr>
+        <p:spPr>
+          <a:xfrm>
+            <a:off x="6995159" y="4480560"/>
+            <a:ext cx="3246120" cy="1481328"/>
+          </a:xfrm>
+          <a:prstGeom prst="rect">
+            <a:avLst/>
+          </a:prstGeom>
+          <a:solidFill>
+            <a:srgbClr val="3A4A5A"/>
+          </a:solidFill>
+          <a:ln>
+            <a:noFill/>
+          </a:ln>
+        </p:spPr>
+        <p:style>
+          <a:lnRef idx="1">
+            <a:schemeClr val="accent1"/>
+          </a:lnRef>
+          <a:fillRef idx="3">
+            <a:schemeClr val="accent1"/>
+          </a:fillRef>
+          <a:effectRef idx="2">
+            <a:schemeClr val="accent1"/>
+          </a:effectRef>
+          <a:fontRef idx="minor">
+            <a:schemeClr val="lt1"/>
+          </a:fontRef>
+        </p:style>
+        <p:txBody>
+          <a:bodyPr rtlCol="0" anchor="ctr"/>
+          <a:lstStyle/>
+          <a:p>
+            <a:pPr algn="ctr"/>
+          </a:p>
+        </p:txBody>
+      </p:sp>
+      <p:sp>
+        <p:nvSpPr>
+          <p:cNvPr id="26" name="TextBox 25"/>
+          <p:cNvSpPr txBox="1"/>
+          <p:nvPr/>
+        </p:nvSpPr>
+        <p:spPr>
+          <a:xfrm>
+            <a:off x="7104888" y="4572000"/>
+            <a:ext cx="3063239" cy="320040"/>
+          </a:xfrm>
+          <a:prstGeom prst="rect">
+            <a:avLst/>
+          </a:prstGeom>
+          <a:noFill/>
+        </p:spPr>
+        <p:txBody>
+          <a:bodyPr wrap="square">
+            <a:spAutoFit/>
+          </a:bodyPr>
+          <a:lstStyle/>
+          <a:p>
+            <a:r>
+              <a:rPr sz="1000" b="0">
+                <a:solidFill>
+                  <a:srgbClr val="EBE4D3"/>
+                </a:solidFill>
+                <a:latin typeface="Courier New"/>
+              </a:rPr>
+              <a:t>SERVIZIO</a:t>
+            </a:r>
+          </a:p>
+        </p:txBody>
+      </p:sp>
+      <p:sp>
+        <p:nvSpPr>
+          <p:cNvPr id="27" name="TextBox 26"/>
+          <p:cNvSpPr txBox="1"/>
+          <p:nvPr/>
+        </p:nvSpPr>
+        <p:spPr>
+          <a:xfrm>
+            <a:off x="7104888" y="4937760"/>
+            <a:ext cx="3063239" cy="685800"/>
+          </a:xfrm>
+          <a:prstGeom prst="rect">
+            <a:avLst/>
+          </a:prstGeom>
+          <a:noFill/>
+        </p:spPr>
+        <p:txBody>
+          <a:bodyPr wrap="square">
+            <a:spAutoFit/>
+          </a:bodyPr>
+          <a:lstStyle/>
+          <a:p>
+            <a:r>
+              <a:rPr sz="1900" b="1">
+                <a:solidFill>
+                  <a:srgbClr val="F3EDE1"/>
+                </a:solidFill>
+                <a:latin typeface="Georgia"/>
+              </a:rPr>
+              <a:t>Customer Care</a:t>
+            </a:r>
+          </a:p>
+        </p:txBody>
+      </p:sp>
+      <p:sp>
+        <p:nvSpPr>
+          <p:cNvPr id="28" name="Rectangle 27"/>
+          <p:cNvSpPr/>
+          <p:nvPr/>
+        </p:nvSpPr>
+        <p:spPr>
+          <a:xfrm>
+            <a:off x="10332719" y="4480560"/>
+            <a:ext cx="3246120" cy="1481328"/>
+          </a:xfrm>
+          <a:prstGeom prst="rect">
+            <a:avLst/>
+          </a:prstGeom>
+          <a:solidFill>
+            <a:srgbClr val="6A4A3A"/>
+          </a:solidFill>
+          <a:ln>
+            <a:noFill/>
+          </a:ln>
+        </p:spPr>
+        <p:style>
+          <a:lnRef idx="1">
+            <a:schemeClr val="accent1"/>
+          </a:lnRef>
+          <a:fillRef idx="3">
+            <a:schemeClr val="accent1"/>
+          </a:fillRef>
+          <a:effectRef idx="2">
+            <a:schemeClr val="accent1"/>
+          </a:effectRef>
+          <a:fontRef idx="minor">
+            <a:schemeClr val="lt1"/>
+          </a:fontRef>
+        </p:style>
+        <p:txBody>
+          <a:bodyPr rtlCol="0" anchor="ctr"/>
+          <a:lstStyle/>
+          <a:p>
+            <a:pPr algn="ctr"/>
+          </a:p>
+        </p:txBody>
+      </p:sp>
+      <p:sp>
+        <p:nvSpPr>
+          <p:cNvPr id="29" name="TextBox 28"/>
+          <p:cNvSpPr txBox="1"/>
+          <p:nvPr/>
+        </p:nvSpPr>
+        <p:spPr>
+          <a:xfrm>
+            <a:off x="10442447" y="4572000"/>
+            <a:ext cx="3063239" cy="320040"/>
+          </a:xfrm>
+          <a:prstGeom prst="rect">
+            <a:avLst/>
+          </a:prstGeom>
+          <a:noFill/>
+        </p:spPr>
+        <p:txBody>
+          <a:bodyPr wrap="square">
+            <a:spAutoFit/>
+          </a:bodyPr>
+          <a:lstStyle/>
+          <a:p>
+            <a:r>
+              <a:rPr sz="1000" b="0">
+                <a:solidFill>
+                  <a:srgbClr val="EBE4D3"/>
+                </a:solidFill>
+                <a:latin typeface="Courier New"/>
+              </a:rPr>
+              <a:t>VALUTAZIONE</a:t>
+            </a:r>
+          </a:p>
+        </p:txBody>
+      </p:sp>
+      <p:sp>
+        <p:nvSpPr>
+          <p:cNvPr id="30" name="TextBox 29"/>
+          <p:cNvSpPr txBox="1"/>
+          <p:nvPr/>
+        </p:nvSpPr>
+        <p:spPr>
+          <a:xfrm>
+            <a:off x="10442447" y="4937760"/>
+            <a:ext cx="3063239" cy="685800"/>
+          </a:xfrm>
+          <a:prstGeom prst="rect">
+            <a:avLst/>
+          </a:prstGeom>
+          <a:noFill/>
+        </p:spPr>
+        <p:txBody>
+          <a:bodyPr wrap="square">
+            <a:spAutoFit/>
+          </a:bodyPr>
+          <a:lstStyle/>
+          <a:p>
+            <a:r>
+              <a:rPr sz="1900" b="1">
+                <a:solidFill>
+                  <a:srgbClr val="F3EDE1"/>
+                </a:solidFill>
+                <a:latin typeface="Georgia"/>
+              </a:rPr>
+              <a:t>Review &amp; Forum</a:t>
+            </a:r>
+          </a:p>
+        </p:txBody>
+      </p:sp>
+      <p:sp>
+        <p:nvSpPr>
+          <p:cNvPr id="31" name="Rectangle 30"/>
+          <p:cNvSpPr/>
+          <p:nvPr/>
+        </p:nvSpPr>
+        <p:spPr>
+          <a:xfrm>
+            <a:off x="13670280" y="4480560"/>
+            <a:ext cx="3246120" cy="1481328"/>
+          </a:xfrm>
+          <a:prstGeom prst="rect">
+            <a:avLst/>
+          </a:prstGeom>
+          <a:solidFill>
+            <a:srgbClr val="4A4A5A"/>
+          </a:solidFill>
+          <a:ln>
+            <a:noFill/>
+          </a:ln>
+        </p:spPr>
+        <p:style>
+          <a:lnRef idx="1">
+            <a:schemeClr val="accent1"/>
+          </a:lnRef>
+          <a:fillRef idx="3">
+            <a:schemeClr val="accent1"/>
+          </a:fillRef>
+          <a:effectRef idx="2">
+            <a:schemeClr val="accent1"/>
+          </a:effectRef>
+          <a:fontRef idx="minor">
+            <a:schemeClr val="lt1"/>
+          </a:fontRef>
+        </p:style>
+        <p:txBody>
+          <a:bodyPr rtlCol="0" anchor="ctr"/>
+          <a:lstStyle/>
+          <a:p>
+            <a:pPr algn="ctr"/>
+          </a:p>
+        </p:txBody>
+      </p:sp>
+      <p:sp>
+        <p:nvSpPr>
+          <p:cNvPr id="32" name="TextBox 31"/>
+          <p:cNvSpPr txBox="1"/>
+          <p:nvPr/>
+        </p:nvSpPr>
+        <p:spPr>
+          <a:xfrm>
+            <a:off x="13780007" y="4572000"/>
+            <a:ext cx="3063239" cy="320040"/>
+          </a:xfrm>
+          <a:prstGeom prst="rect">
+            <a:avLst/>
+          </a:prstGeom>
+          <a:noFill/>
+        </p:spPr>
+        <p:txBody>
+          <a:bodyPr wrap="square">
+            <a:spAutoFit/>
+          </a:bodyPr>
+          <a:lstStyle/>
+          <a:p>
+            <a:r>
+              <a:rPr sz="1000" b="0">
+                <a:solidFill>
+                  <a:srgbClr val="EBE4D3"/>
+                </a:solidFill>
+                <a:latin typeface="Courier New"/>
+              </a:rPr>
+              <a:t>CONOSCENZA</a:t>
+            </a:r>
+          </a:p>
+        </p:txBody>
+      </p:sp>
+      <p:sp>
+        <p:nvSpPr>
+          <p:cNvPr id="33" name="TextBox 32"/>
+          <p:cNvSpPr txBox="1"/>
+          <p:nvPr/>
+        </p:nvSpPr>
+        <p:spPr>
+          <a:xfrm>
+            <a:off x="13780007" y="4937760"/>
+            <a:ext cx="3063239" cy="685800"/>
+          </a:xfrm>
+          <a:prstGeom prst="rect">
+            <a:avLst/>
+          </a:prstGeom>
+          <a:noFill/>
+        </p:spPr>
+        <p:txBody>
+          <a:bodyPr wrap="square">
+            <a:spAutoFit/>
+          </a:bodyPr>
+          <a:lstStyle/>
+          <a:p>
+            <a:r>
+              <a:rPr sz="1900" b="1">
+                <a:solidFill>
+                  <a:srgbClr val="F3EDE1"/>
+                </a:solidFill>
+                <a:latin typeface="Georgia"/>
+              </a:rPr>
+              <a:t>Desk Research</a:t>
+            </a:r>
+          </a:p>
+        </p:txBody>
+      </p:sp>
+      <p:sp>
+        <p:nvSpPr>
+          <p:cNvPr id="34" name="Rectangle 33"/>
+          <p:cNvSpPr/>
+          <p:nvPr/>
+        </p:nvSpPr>
+        <p:spPr>
+          <a:xfrm>
+            <a:off x="320040" y="6035040"/>
+            <a:ext cx="3246120" cy="1481328"/>
+          </a:xfrm>
+          <a:prstGeom prst="rect">
+            <a:avLst/>
+          </a:prstGeom>
+          <a:solidFill>
+            <a:srgbClr val="5A6A4A"/>
+          </a:solidFill>
+          <a:ln>
+            <a:noFill/>
+          </a:ln>
+        </p:spPr>
+        <p:style>
+          <a:lnRef idx="1">
+            <a:schemeClr val="accent1"/>
+          </a:lnRef>
+          <a:fillRef idx="3">
+            <a:schemeClr val="accent1"/>
+          </a:fillRef>
+          <a:effectRef idx="2">
+            <a:schemeClr val="accent1"/>
+          </a:effectRef>
+          <a:fontRef idx="minor">
+            <a:schemeClr val="lt1"/>
+          </a:fontRef>
+        </p:style>
+        <p:txBody>
+          <a:bodyPr rtlCol="0" anchor="ctr"/>
+          <a:lstStyle/>
+          <a:p>
+            <a:pPr algn="ctr"/>
+          </a:p>
+        </p:txBody>
+      </p:sp>
+      <p:sp>
+        <p:nvSpPr>
+          <p:cNvPr id="35" name="TextBox 34"/>
+          <p:cNvSpPr txBox="1"/>
+          <p:nvPr/>
+        </p:nvSpPr>
+        <p:spPr>
+          <a:xfrm>
+            <a:off x="429768" y="6126480"/>
+            <a:ext cx="3063239" cy="320040"/>
+          </a:xfrm>
+          <a:prstGeom prst="rect">
+            <a:avLst/>
+          </a:prstGeom>
+          <a:noFill/>
+        </p:spPr>
+        <p:txBody>
+          <a:bodyPr wrap="square">
+            <a:spAutoFit/>
+          </a:bodyPr>
+          <a:lstStyle/>
+          <a:p>
+            <a:r>
+              <a:rPr sz="1000" b="0">
+                <a:solidFill>
+                  <a:srgbClr val="EBE4D3"/>
+                </a:solidFill>
+                <a:latin typeface="Courier New"/>
+              </a:rPr>
+              <a:t>CULTURA</a:t>
+            </a:r>
+          </a:p>
+        </p:txBody>
+      </p:sp>
+      <p:sp>
+        <p:nvSpPr>
+          <p:cNvPr id="36" name="TextBox 35"/>
+          <p:cNvSpPr txBox="1"/>
+          <p:nvPr/>
+        </p:nvSpPr>
+        <p:spPr>
+          <a:xfrm>
+            <a:off x="429768" y="6492240"/>
+            <a:ext cx="3063239" cy="685800"/>
+          </a:xfrm>
+          <a:prstGeom prst="rect">
+            <a:avLst/>
+          </a:prstGeom>
+          <a:noFill/>
+        </p:spPr>
+        <p:txBody>
+          <a:bodyPr wrap="square">
+            <a:spAutoFit/>
+          </a:bodyPr>
+          <a:lstStyle/>
+          <a:p>
+            <a:r>
+              <a:rPr sz="1900" b="1">
+                <a:solidFill>
+                  <a:srgbClr val="F3EDE1"/>
+                </a:solidFill>
+                <a:latin typeface="Georgia"/>
+              </a:rPr>
+              <a:t>Trend Report</a:t>
+            </a:r>
+          </a:p>
+        </p:txBody>
+      </p:sp>
+      <p:sp>
+        <p:nvSpPr>
+          <p:cNvPr id="37" name="Rectangle 36"/>
+          <p:cNvSpPr/>
+          <p:nvPr/>
+        </p:nvSpPr>
+        <p:spPr>
+          <a:xfrm>
+            <a:off x="3657600" y="6035040"/>
+            <a:ext cx="3246120" cy="1481328"/>
+          </a:xfrm>
+          <a:prstGeom prst="rect">
+            <a:avLst/>
+          </a:prstGeom>
+          <a:solidFill>
+            <a:srgbClr val="6A5A5A"/>
+          </a:solidFill>
+          <a:ln>
+            <a:noFill/>
+          </a:ln>
+        </p:spPr>
+        <p:style>
+          <a:lnRef idx="1">
+            <a:schemeClr val="accent1"/>
+          </a:lnRef>
+          <a:fillRef idx="3">
+            <a:schemeClr val="accent1"/>
+          </a:fillRef>
+          <a:effectRef idx="2">
+            <a:schemeClr val="accent1"/>
+          </a:effectRef>
+          <a:fontRef idx="minor">
+            <a:schemeClr val="lt1"/>
+          </a:fontRef>
+        </p:style>
+        <p:txBody>
+          <a:bodyPr rtlCol="0" anchor="ctr"/>
+          <a:lstStyle/>
+          <a:p>
+            <a:pPr algn="ctr"/>
+          </a:p>
+        </p:txBody>
+      </p:sp>
+      <p:sp>
+        <p:nvSpPr>
+          <p:cNvPr id="38" name="TextBox 37"/>
+          <p:cNvSpPr txBox="1"/>
+          <p:nvPr/>
+        </p:nvSpPr>
+        <p:spPr>
+          <a:xfrm>
+            <a:off x="3767328" y="6126480"/>
+            <a:ext cx="3063239" cy="320040"/>
+          </a:xfrm>
+          <a:prstGeom prst="rect">
+            <a:avLst/>
+          </a:prstGeom>
+          <a:noFill/>
+        </p:spPr>
+        <p:txBody>
+          <a:bodyPr wrap="square">
+            <a:spAutoFit/>
+          </a:bodyPr>
+          <a:lstStyle/>
+          <a:p>
+            <a:r>
+              <a:rPr sz="1000" b="0">
+                <a:solidFill>
+                  <a:srgbClr val="EBE4D3"/>
+                </a:solidFill>
+                <a:latin typeface="Courier New"/>
+              </a:rPr>
+              <a:t>ETNOGRAFIA</a:t>
+            </a:r>
+          </a:p>
+        </p:txBody>
+      </p:sp>
+      <p:sp>
+        <p:nvSpPr>
+          <p:cNvPr id="39" name="TextBox 38"/>
+          <p:cNvSpPr txBox="1"/>
+          <p:nvPr/>
+        </p:nvSpPr>
+        <p:spPr>
+          <a:xfrm>
+            <a:off x="3767328" y="6492240"/>
+            <a:ext cx="3063239" cy="685800"/>
+          </a:xfrm>
+          <a:prstGeom prst="rect">
+            <a:avLst/>
+          </a:prstGeom>
+          <a:noFill/>
+        </p:spPr>
+        <p:txBody>
+          <a:bodyPr wrap="square">
+            <a:spAutoFit/>
+          </a:bodyPr>
+          <a:lstStyle/>
+          <a:p>
+            <a:r>
+              <a:rPr sz="1900" b="1">
+                <a:solidFill>
+                  <a:srgbClr val="F3EDE1"/>
+                </a:solidFill>
+                <a:latin typeface="Georgia"/>
+              </a:rPr>
+              <a:t>Digital Ethnography</a:t>
+            </a:r>
+          </a:p>
+        </p:txBody>
+      </p:sp>
+      <p:sp>
+        <p:nvSpPr>
+          <p:cNvPr id="40" name="Rectangle 39"/>
+          <p:cNvSpPr/>
+          <p:nvPr/>
+        </p:nvSpPr>
+        <p:spPr>
+          <a:xfrm>
+            <a:off x="6995159" y="6035040"/>
+            <a:ext cx="3246120" cy="1481328"/>
+          </a:xfrm>
+          <a:prstGeom prst="rect">
+            <a:avLst/>
+          </a:prstGeom>
+          <a:solidFill>
+            <a:srgbClr val="4A5A6A"/>
+          </a:solidFill>
+          <a:ln>
+            <a:noFill/>
+          </a:ln>
+        </p:spPr>
+        <p:style>
+          <a:lnRef idx="1">
+            <a:schemeClr val="accent1"/>
+          </a:lnRef>
+          <a:fillRef idx="3">
+            <a:schemeClr val="accent1"/>
+          </a:fillRef>
+          <a:effectRef idx="2">
+            <a:schemeClr val="accent1"/>
+          </a:effectRef>
+          <a:fontRef idx="minor">
+            <a:schemeClr val="lt1"/>
+          </a:fontRef>
+        </p:style>
+        <p:txBody>
+          <a:bodyPr rtlCol="0" anchor="ctr"/>
+          <a:lstStyle/>
+          <a:p>
+            <a:pPr algn="ctr"/>
+          </a:p>
+        </p:txBody>
+      </p:sp>
+      <p:sp>
+        <p:nvSpPr>
+          <p:cNvPr id="41" name="TextBox 40"/>
+          <p:cNvSpPr txBox="1"/>
+          <p:nvPr/>
+        </p:nvSpPr>
+        <p:spPr>
+          <a:xfrm>
+            <a:off x="7104888" y="6126480"/>
+            <a:ext cx="3063239" cy="320040"/>
+          </a:xfrm>
+          <a:prstGeom prst="rect">
+            <a:avLst/>
+          </a:prstGeom>
+          <a:noFill/>
+        </p:spPr>
+        <p:txBody>
+          <a:bodyPr wrap="square">
+            <a:spAutoFit/>
+          </a:bodyPr>
+          <a:lstStyle/>
+          <a:p>
+            <a:r>
+              <a:rPr sz="1000" b="0">
+                <a:solidFill>
+                  <a:srgbClr val="EBE4D3"/>
+                </a:solidFill>
+                <a:latin typeface="Courier New"/>
+              </a:rPr>
+              <a:t>RELAZIONI</a:t>
+            </a:r>
+          </a:p>
+        </p:txBody>
+      </p:sp>
+      <p:sp>
+        <p:nvSpPr>
+          <p:cNvPr id="42" name="TextBox 41"/>
+          <p:cNvSpPr txBox="1"/>
+          <p:nvPr/>
+        </p:nvSpPr>
+        <p:spPr>
+          <a:xfrm>
+            <a:off x="7104888" y="6492240"/>
+            <a:ext cx="3063239" cy="685800"/>
+          </a:xfrm>
+          <a:prstGeom prst="rect">
+            <a:avLst/>
+          </a:prstGeom>
+          <a:noFill/>
+        </p:spPr>
+        <p:txBody>
+          <a:bodyPr wrap="square">
+            <a:spAutoFit/>
+          </a:bodyPr>
+          <a:lstStyle/>
+          <a:p>
+            <a:r>
+              <a:rPr sz="1900" b="1">
+                <a:solidFill>
+                  <a:srgbClr val="F3EDE1"/>
+                </a:solidFill>
+                <a:latin typeface="Georgia"/>
+              </a:rPr>
+              <a:t>Network Analysis</a:t>
+            </a:r>
+          </a:p>
+        </p:txBody>
+      </p:sp>
+      <p:sp>
+        <p:nvSpPr>
+          <p:cNvPr id="43" name="Rectangle 42"/>
+          <p:cNvSpPr/>
+          <p:nvPr/>
+        </p:nvSpPr>
+        <p:spPr>
+          <a:xfrm>
+            <a:off x="10332719" y="6035040"/>
+            <a:ext cx="3246120" cy="1481328"/>
+          </a:xfrm>
+          <a:prstGeom prst="rect">
+            <a:avLst/>
+          </a:prstGeom>
+          <a:solidFill>
+            <a:srgbClr val="5A5A3A"/>
+          </a:solidFill>
+          <a:ln>
+            <a:noFill/>
+          </a:ln>
+        </p:spPr>
+        <p:style>
+          <a:lnRef idx="1">
+            <a:schemeClr val="accent1"/>
+          </a:lnRef>
+          <a:fillRef idx="3">
+            <a:schemeClr val="accent1"/>
+          </a:fillRef>
+          <a:effectRef idx="2">
+            <a:schemeClr val="accent1"/>
+          </a:effectRef>
+          <a:fontRef idx="minor">
+            <a:schemeClr val="lt1"/>
+          </a:fontRef>
+        </p:style>
+        <p:txBody>
+          <a:bodyPr rtlCol="0" anchor="ctr"/>
+          <a:lstStyle/>
+          <a:p>
+            <a:pPr algn="ctr"/>
+          </a:p>
+        </p:txBody>
+      </p:sp>
+      <p:sp>
+        <p:nvSpPr>
+          <p:cNvPr id="44" name="TextBox 43"/>
+          <p:cNvSpPr txBox="1"/>
+          <p:nvPr/>
+        </p:nvSpPr>
+        <p:spPr>
+          <a:xfrm>
+            <a:off x="10442447" y="6126480"/>
+            <a:ext cx="3063239" cy="320040"/>
+          </a:xfrm>
+          <a:prstGeom prst="rect">
+            <a:avLst/>
+          </a:prstGeom>
+          <a:noFill/>
+        </p:spPr>
+        <p:txBody>
+          <a:bodyPr wrap="square">
+            <a:spAutoFit/>
+          </a:bodyPr>
+          <a:lstStyle/>
+          <a:p>
+            <a:r>
+              <a:rPr sz="1000" b="0">
+                <a:solidFill>
+                  <a:srgbClr val="EBE4D3"/>
+                </a:solidFill>
+                <a:latin typeface="Courier New"/>
+              </a:rPr>
+              <a:t>OWNED</a:t>
+            </a:r>
+          </a:p>
+        </p:txBody>
+      </p:sp>
+      <p:sp>
+        <p:nvSpPr>
+          <p:cNvPr id="45" name="TextBox 44"/>
+          <p:cNvSpPr txBox="1"/>
+          <p:nvPr/>
+        </p:nvSpPr>
+        <p:spPr>
+          <a:xfrm>
+            <a:off x="10442447" y="6492240"/>
+            <a:ext cx="3063239" cy="685800"/>
+          </a:xfrm>
+          <a:prstGeom prst="rect">
+            <a:avLst/>
+          </a:prstGeom>
+          <a:noFill/>
+        </p:spPr>
+        <p:txBody>
+          <a:bodyPr wrap="square">
+            <a:spAutoFit/>
+          </a:bodyPr>
+          <a:lstStyle/>
+          <a:p>
+            <a:r>
+              <a:rPr sz="1900" b="1">
+                <a:solidFill>
+                  <a:srgbClr val="F3EDE1"/>
+                </a:solidFill>
+                <a:latin typeface="Georgia"/>
+              </a:rPr>
+              <a:t>Dati proprietari</a:t>
+            </a:r>
+          </a:p>
+        </p:txBody>
+      </p:sp>
+      <p:sp>
+        <p:nvSpPr>
+          <p:cNvPr id="46" name="Rectangle 45"/>
+          <p:cNvSpPr/>
+          <p:nvPr/>
+        </p:nvSpPr>
+        <p:spPr>
+          <a:xfrm>
+            <a:off x="13670280" y="6035040"/>
+            <a:ext cx="3246120" cy="1481328"/>
+          </a:xfrm>
+          <a:prstGeom prst="rect">
+            <a:avLst/>
+          </a:prstGeom>
+          <a:solidFill>
+            <a:srgbClr val="1A1714"/>
+          </a:solidFill>
+          <a:ln>
+            <a:noFill/>
+          </a:ln>
+        </p:spPr>
+        <p:style>
+          <a:lnRef idx="1">
+            <a:schemeClr val="accent1"/>
+          </a:lnRef>
+          <a:fillRef idx="3">
+            <a:schemeClr val="accent1"/>
+          </a:fillRef>
+          <a:effectRef idx="2">
+            <a:schemeClr val="accent1"/>
+          </a:effectRef>
+          <a:fontRef idx="minor">
+            <a:schemeClr val="lt1"/>
+          </a:fontRef>
+        </p:style>
+        <p:txBody>
+          <a:bodyPr rtlCol="0" anchor="ctr"/>
+          <a:lstStyle/>
+          <a:p>
+            <a:pPr algn="ctr"/>
+          </a:p>
+        </p:txBody>
+      </p:sp>
+      <p:sp>
+        <p:nvSpPr>
+          <p:cNvPr id="47" name="TextBox 46"/>
+          <p:cNvSpPr txBox="1"/>
+          <p:nvPr/>
+        </p:nvSpPr>
+        <p:spPr>
+          <a:xfrm>
+            <a:off x="13780007" y="6126480"/>
+            <a:ext cx="3063239" cy="320040"/>
+          </a:xfrm>
+          <a:prstGeom prst="rect">
+            <a:avLst/>
+          </a:prstGeom>
+          <a:noFill/>
+        </p:spPr>
+        <p:txBody>
+          <a:bodyPr wrap="square">
+            <a:spAutoFit/>
+          </a:bodyPr>
+          <a:lstStyle/>
+          <a:p>
+            <a:r>
+              <a:rPr sz="1000" b="0">
+                <a:solidFill>
+                  <a:srgbClr val="EBE4D3"/>
+                </a:solidFill>
+                <a:latin typeface="Courier New"/>
+              </a:rPr>
+              <a:t>NUOVA FRONTIERA</a:t>
+            </a:r>
+          </a:p>
+        </p:txBody>
+      </p:sp>
+      <p:sp>
+        <p:nvSpPr>
+          <p:cNvPr id="48" name="TextBox 47"/>
+          <p:cNvSpPr txBox="1"/>
+          <p:nvPr/>
+        </p:nvSpPr>
+        <p:spPr>
+          <a:xfrm>
+            <a:off x="13780007" y="6492240"/>
+            <a:ext cx="3063239" cy="685800"/>
+          </a:xfrm>
+          <a:prstGeom prst="rect">
+            <a:avLst/>
+          </a:prstGeom>
+          <a:noFill/>
+        </p:spPr>
+        <p:txBody>
+          <a:bodyPr wrap="square">
+            <a:spAutoFit/>
+          </a:bodyPr>
+          <a:lstStyle/>
+          <a:p>
+            <a:r>
+              <a:rPr sz="1900" b="1">
+                <a:solidFill>
+                  <a:srgbClr val="F3EDE1"/>
+                </a:solidFill>
+                <a:latin typeface="Georgia"/>
+              </a:rPr>
+              <a:t>GEO &amp; AI Visibility</a:t>
+            </a:r>
+          </a:p>
+        </p:txBody>
+      </p:sp>
+      <p:sp>
+        <p:nvSpPr>
+          <p:cNvPr id="49" name="TextBox 48"/>
+          <p:cNvSpPr txBox="1"/>
+          <p:nvPr/>
+        </p:nvSpPr>
+        <p:spPr>
+          <a:xfrm>
+            <a:off x="320040" y="8321040"/>
+            <a:ext cx="17373600" cy="640080"/>
+          </a:xfrm>
+          <a:prstGeom prst="rect">
+            <a:avLst/>
+          </a:prstGeom>
+          <a:noFill/>
+        </p:spPr>
+        <p:txBody>
+          <a:bodyPr wrap="square">
+            <a:spAutoFit/>
+          </a:bodyPr>
+          <a:lstStyle/>
+          <a:p>
+            <a:r>
+              <a:rPr sz="1200" b="0">
+                <a:solidFill>
+                  <a:srgbClr val="8A8175"/>
+                </a:solidFill>
+                <a:latin typeface="Courier New"/>
+              </a:rPr>
+              <a:t>NOTA RELATORE: "Ogni box e una finestra diversa sul mercato. Il vantaggio non sta nell'averne una — sta nel saper scegliere quale aprire."</a:t>
             </a:r>
           </a:p>
         </p:txBody>

</xml_diff>